<commit_message>
Reframe optimization loop as smarter convergence detection
The issue is the convergence check (FixedPoint), not the loop itself.
Softened language: observation on 13 benchmarks, not a definitive claim.
Aligns with dev team direction: better loop condition, not loop removal.

Co-Authored-By: Claude Opus 4.6 <noreply@anthropic.com>
</commit_message>
<xml_diff>
--- a/investigation/qiskit_transpiler_optimizations.pptx
+++ b/investigation/qiskit_transpiler_optimizations.pptx
@@ -3207,7 +3207,7 @@
               </a:defRPr>
             </a:pPr>
             <a:r>
-              <a:t>1.  Optimization Loop: redundant iterations in the L2 loop</a:t>
+              <a:t>1.  Optimization Loop: smarter convergence detection for L2</a:t>
             </a:r>
           </a:p>
           <a:p>
@@ -3337,7 +3337,7 @@
               </a:defRPr>
             </a:pPr>
             <a:r>
-              <a:t>1. Optimization Loop: The L2 Loop Does No Useful Work After Iteration 1</a:t>
+              <a:t>1. Optimization Loop: Smarter Convergence Detection for Level 2</a:t>
             </a:r>
           </a:p>
         </p:txBody>
@@ -3387,7 +3387,7 @@
         <p:spPr>
           <a:xfrm>
             <a:off x="457200" y="1234440"/>
-            <a:ext cx="3840480" cy="1645920"/>
+            <a:ext cx="3840480" cy="2011680"/>
           </a:xfrm>
           <a:prstGeom prst="rect">
             <a:avLst/>
@@ -3428,7 +3428,7 @@
               </a:defRPr>
             </a:pPr>
             <a:r>
-              <a:t>to detect convergence -- minimum 2 iterations always</a:t>
+              <a:t>to detect convergence</a:t>
             </a:r>
           </a:p>
           <a:p>
@@ -3444,7 +3444,7 @@
               </a:defRPr>
             </a:pPr>
             <a:r>
-              <a:t>Iteration 2+ only confirms "nothing changed"</a:t>
+              <a:t>Always requires a redundant "confirmation" iteration</a:t>
             </a:r>
           </a:p>
           <a:p>
@@ -3460,7 +3460,55 @@
               </a:defRPr>
             </a:pPr>
             <a:r>
-              <a:t>Wastes 33-50% of optimization stage time</a:t>
+              <a:t>that re-runs all passes just to verify metrics</a:t>
+            </a:r>
+          </a:p>
+          <a:p>
+            <a:pPr>
+              <a:spcAft>
+                <a:spcPts val="400"/>
+              </a:spcAft>
+              <a:defRPr sz="1200" b="0">
+                <a:solidFill>
+                  <a:srgbClr val="333333"/>
+                </a:solidFill>
+                <a:latin typeface="Calibri"/>
+              </a:defRPr>
+            </a:pPr>
+            <a:r>
+              <a:t>haven't changed</a:t>
+            </a:r>
+          </a:p>
+          <a:p>
+            <a:pPr>
+              <a:spcAft>
+                <a:spcPts val="400"/>
+              </a:spcAft>
+              <a:defRPr sz="1200" b="0">
+                <a:solidFill>
+                  <a:srgbClr val="333333"/>
+                </a:solidFill>
+                <a:latin typeface="Calibri"/>
+              </a:defRPr>
+            </a:pPr>
+            <a:r>
+              <a:t>The loop structure is sound -- the issue is the</a:t>
+            </a:r>
+          </a:p>
+          <a:p>
+            <a:pPr>
+              <a:spcAft>
+                <a:spcPts val="400"/>
+              </a:spcAft>
+              <a:defRPr sz="1200" b="0">
+                <a:solidFill>
+                  <a:srgbClr val="333333"/>
+                </a:solidFill>
+                <a:latin typeface="Calibri"/>
+              </a:defRPr>
+            </a:pPr>
+            <a:r>
+              <a:t>convergence check</a:t>
             </a:r>
           </a:p>
         </p:txBody>
@@ -3496,7 +3544,7 @@
               </a:defRPr>
             </a:pPr>
             <a:r>
-              <a:t>Key Finding</a:t>
+              <a:t>Observation (13 benchmarks)</a:t>
             </a:r>
           </a:p>
         </p:txBody>
@@ -3510,7 +3558,7 @@
         <p:spPr>
           <a:xfrm>
             <a:off x="4754880" y="1234440"/>
-            <a:ext cx="4114800" cy="1645920"/>
+            <a:ext cx="4114800" cy="2011680"/>
           </a:xfrm>
           <a:prstGeom prst="rect">
             <a:avLst/>
@@ -3535,7 +3583,7 @@
               </a:defRPr>
             </a:pPr>
             <a:r>
-              <a:t>Pre-loop passes (ConsolidateBlocks, UnitarySynthesis)</a:t>
+              <a:t>On 13 circuits (QFT, QV, ESU2, QAOA, BV,</a:t>
             </a:r>
           </a:p>
           <a:p>
@@ -3551,7 +3599,7 @@
               </a:defRPr>
             </a:pPr>
             <a:r>
-              <a:t>handle all 2Q reduction before the loop starts</a:t>
+              <a:t>Heisenberg at 50-100Q on FakeTorino):</a:t>
             </a:r>
           </a:p>
           <a:p>
@@ -3567,7 +3615,7 @@
               </a:defRPr>
             </a:pPr>
             <a:r>
-              <a:t>Loop passes contribute 0 additional 2Q gates</a:t>
+              <a:t>Pre-loop passes (ConsolidateBlocks, UnitarySynthesis)</a:t>
             </a:r>
           </a:p>
           <a:p>
@@ -3583,7 +3631,7 @@
               </a:defRPr>
             </a:pPr>
             <a:r>
-              <a:t>on 12 out of 13 benchmark circuits</a:t>
+              <a:t>handle the bulk of 2Q gate reduction</a:t>
             </a:r>
           </a:p>
           <a:p>
@@ -3591,7 +3639,7 @@
               <a:spcAft>
                 <a:spcPts val="400"/>
               </a:spcAft>
-              <a:defRPr sz="1200" b="1">
+              <a:defRPr sz="1200" b="0">
                 <a:solidFill>
                   <a:srgbClr val="333333"/>
                 </a:solidFill>
@@ -3599,7 +3647,23 @@
               </a:defRPr>
             </a:pPr>
             <a:r>
-              <a:t>Removing the loop entirely: identical gate counts</a:t>
+              <a:t>Final iteration is always a no-op confirmation</a:t>
+            </a:r>
+          </a:p>
+          <a:p>
+            <a:pPr>
+              <a:spcAft>
+                <a:spcPts val="400"/>
+              </a:spcAft>
+              <a:defRPr sz="1200" b="0">
+                <a:solidFill>
+                  <a:srgbClr val="333333"/>
+                </a:solidFill>
+                <a:latin typeface="Calibri"/>
+              </a:defRPr>
+            </a:pPr>
+            <a:r>
+              <a:t>Different workloads may behave differently</a:t>
             </a:r>
           </a:p>
         </p:txBody>
@@ -3612,7 +3676,7 @@
         </p:nvSpPr>
         <p:spPr>
           <a:xfrm>
-            <a:off x="457200" y="3017520"/>
+            <a:off x="457200" y="3200400"/>
             <a:ext cx="8229600" cy="274320"/>
           </a:xfrm>
           <a:prstGeom prst="rect">
@@ -3635,7 +3699,7 @@
               </a:defRPr>
             </a:pPr>
             <a:r>
-              <a:t>Results: 13 Circuits on FakeTorino (133Q), Optimization Level 2</a:t>
+              <a:t>Changed-Flag Prototype: Iterations Saved, No Regressions</a:t>
             </a:r>
           </a:p>
         </p:txBody>
@@ -3649,8 +3713,8 @@
           <p:nvPr/>
         </p:nvGraphicFramePr>
         <p:xfrm>
-          <a:off x="457200" y="3383280"/>
-          <a:ext cx="6858000" cy="2286000"/>
+          <a:off x="457200" y="3566160"/>
+          <a:ext cx="7315200" cy="2103120"/>
         </p:xfrm>
         <a:graphic>
           <a:graphicData uri="http://schemas.openxmlformats.org/drawingml/2006/table">
@@ -3659,13 +3723,13 @@
                 <a:tableStyleId>{5C22544A-7EE6-4342-B048-85BDC9FD1C3A}</a:tableStyleId>
               </a:tblPr>
               <a:tblGrid>
-                <a:gridCol w="2011680"/>
-                <a:gridCol w="1005840"/>
-                <a:gridCol w="1005840"/>
-                <a:gridCol w="1371600"/>
+                <a:gridCol w="1828800"/>
+                <a:gridCol w="1280160"/>
+                <a:gridCol w="1463040"/>
+                <a:gridCol w="1280160"/>
                 <a:gridCol w="1463040"/>
               </a:tblGrid>
-              <a:tr h="326571">
+              <a:tr h="300445">
                 <a:tc>
                   <a:txBody>
                     <a:bodyPr/>
@@ -3704,7 +3768,7 @@
                         </a:defRPr>
                       </a:pPr>
                       <a:r>
-                        <a:t>Old Iters</a:t>
+                        <a:t>FixedPoint Iters</a:t>
                       </a:r>
                     </a:p>
                   </a:txBody>
@@ -3728,7 +3792,7 @@
                         </a:defRPr>
                       </a:pPr>
                       <a:r>
-                        <a:t>New Iters</a:t>
+                        <a:t>Changed-Flag Iters</a:t>
                       </a:r>
                     </a:p>
                   </a:txBody>
@@ -3787,7 +3851,7 @@
                   </a:tcPr>
                 </a:tc>
               </a:tr>
-              <a:tr h="326571">
+              <a:tr h="300445">
                 <a:tc>
                   <a:txBody>
                     <a:bodyPr/>
@@ -3889,7 +3953,7 @@
                   <a:tcPr anchor="ctr"/>
                 </a:tc>
               </a:tr>
-              <a:tr h="326571">
+              <a:tr h="300445">
                 <a:tc>
                   <a:txBody>
                     <a:bodyPr/>
@@ -4011,7 +4075,7 @@
                   </a:tcPr>
                 </a:tc>
               </a:tr>
-              <a:tr h="326571">
+              <a:tr h="300445">
                 <a:tc>
                   <a:txBody>
                     <a:bodyPr/>
@@ -4113,7 +4177,7 @@
                   <a:tcPr anchor="ctr"/>
                 </a:tc>
               </a:tr>
-              <a:tr h="326571">
+              <a:tr h="300445">
                 <a:tc>
                   <a:txBody>
                     <a:bodyPr/>
@@ -4235,7 +4299,7 @@
                   </a:tcPr>
                 </a:tc>
               </a:tr>
-              <a:tr h="326571">
+              <a:tr h="300445">
                 <a:tc>
                   <a:txBody>
                     <a:bodyPr/>
@@ -4337,7 +4401,7 @@
                   <a:tcPr anchor="ctr"/>
                 </a:tc>
               </a:tr>
-              <a:tr h="326574">
+              <a:tr h="300450">
                 <a:tc>
                   <a:txBody>
                     <a:bodyPr/>
@@ -4494,7 +4558,7 @@
               </a:defRPr>
             </a:pPr>
             <a:r>
-              <a:t>Recommendation: Replace FixedPoint with a direct "changed" boolean flag. Passes return whether they modified 2Q gates; loop exits immediately when no pass reports changes.</a:t>
+              <a:t>Proposal: Replace FixedPoint with a direct "changed" flag -- each pass reports whether it modified 2Q gates, and the loop exits when no pass reports changes. Preserves the loop for circuits where later iterations do find opportunities. Needs validation on broader circuit set.</a:t>
             </a:r>
           </a:p>
         </p:txBody>
@@ -8781,7 +8845,7 @@
                         </a:defRPr>
                       </a:pPr>
                       <a:r>
-                        <a:t>33-50% fewer iterations, 0 regressions</a:t>
+                        <a:t>Eliminates redundant confirmation iteration</a:t>
                       </a:r>
                     </a:p>
                   </a:txBody>
@@ -9078,7 +9142,7 @@
               </a:defRPr>
             </a:pPr>
             <a:r>
-              <a:t>The L2 loop's value was assumed, not measured. Profiling 13 circuits showed it does nothing.</a:t>
+              <a:t>The L2 loop's convergence check (FixedPoint) always forces a redundant confirmation iteration</a:t>
             </a:r>
           </a:p>
           <a:p>

</xml_diff>

<commit_message>
Update slides: optimization loop A/B results + release-build benchmarks
Investigation 1: Updated to reflect opportunity-driven convergence with
rotation tracking. A/B test shows zero regression vs FixedPoint.

Investigation 2: Updated benchmark numbers from release builds (was debug).
QFT-100: 1.58x (rayon ON), 1.88x (serial). Reframed as parallel + cache.

Co-Authored-By: Claude Opus 4.6 <noreply@anthropic.com>
</commit_message>
<xml_diff>
--- a/investigation/qiskit_transpiler_optimizations.pptx
+++ b/investigation/qiskit_transpiler_optimizations.pptx
@@ -3207,7 +3207,7 @@
               </a:defRPr>
             </a:pPr>
             <a:r>
-              <a:t>1.  Optimization Loop: smarter convergence detection for L2</a:t>
+              <a:t>1.  Optimization Loop: opportunity-driven convergence for L2 (zero regression)</a:t>
             </a:r>
           </a:p>
           <a:p>
@@ -3223,7 +3223,7 @@
               </a:defRPr>
             </a:pPr>
             <a:r>
-              <a:t>2.  Compute-Then-Apply: memory access pattern refactoring (15-30% speedup)</a:t>
+              <a:t>2.  Compute-Then-Apply: parallel DAG access refactoring (1.5-1.9x speedup)</a:t>
             </a:r>
           </a:p>
           <a:p>
@@ -3337,7 +3337,7 @@
               </a:defRPr>
             </a:pPr>
             <a:r>
-              <a:t>1. Optimization Loop: Smarter Convergence Detection for Level 2</a:t>
+              <a:t>1. Optimization Loop: Opportunity-Driven Convergence for Level 2</a:t>
             </a:r>
           </a:p>
         </p:txBody>
@@ -3428,7 +3428,7 @@
               </a:defRPr>
             </a:pPr>
             <a:r>
-              <a:t>to detect convergence</a:t>
+              <a:t>Always requires a redundant "confirmation" iteration</a:t>
             </a:r>
           </a:p>
           <a:p>
@@ -3444,7 +3444,7 @@
               </a:defRPr>
             </a:pPr>
             <a:r>
-              <a:t>Always requires a redundant "confirmation" iteration</a:t>
+              <a:t>that re-runs all passes just to verify nothing changed</a:t>
             </a:r>
           </a:p>
           <a:p>
@@ -3459,9 +3459,6 @@
                 <a:latin typeface="Calibri"/>
               </a:defRPr>
             </a:pPr>
-            <a:r>
-              <a:t>that re-runs all passes just to verify metrics</a:t>
-            </a:r>
           </a:p>
           <a:p>
             <a:pPr>
@@ -3476,7 +3473,7 @@
               </a:defRPr>
             </a:pPr>
             <a:r>
-              <a:t>haven't changed</a:t>
+              <a:t>Challenge: Optimize1qGatesDecomposition mutates DAG</a:t>
             </a:r>
           </a:p>
           <a:p>
@@ -3492,7 +3489,7 @@
               </a:defRPr>
             </a:pPr>
             <a:r>
-              <a:t>The loop structure is sound -- the issue is the</a:t>
+              <a:t>unconditionally (replaces 1Q runs even when result is</a:t>
             </a:r>
           </a:p>
           <a:p>
@@ -3508,7 +3505,7 @@
               </a:defRPr>
             </a:pPr>
             <a:r>
-              <a:t>convergence check</a:t>
+              <a:t>identical). A naive "changed?" flag never converges.</a:t>
             </a:r>
           </a:p>
         </p:txBody>
@@ -3544,7 +3541,7 @@
               </a:defRPr>
             </a:pPr>
             <a:r>
-              <a:t>Observation (13 benchmarks)</a:t>
+              <a:t>Solution: Track Opportunity Producers</a:t>
             </a:r>
           </a:p>
         </p:txBody>
@@ -3558,7 +3555,7 @@
         <p:spPr>
           <a:xfrm>
             <a:off x="4754880" y="1234440"/>
-            <a:ext cx="4114800" cy="2011680"/>
+            <a:ext cx="4114800" cy="2286000"/>
           </a:xfrm>
           <a:prstGeom prst="rect">
             <a:avLst/>
@@ -3575,7 +3572,7 @@
               <a:spcAft>
                 <a:spcPts val="400"/>
               </a:spcAft>
-              <a:defRPr sz="1200" b="0">
+              <a:defRPr sz="1200" b="1">
                 <a:solidFill>
                   <a:srgbClr val="333333"/>
                 </a:solidFill>
@@ -3583,7 +3580,7 @@
               </a:defRPr>
             </a:pPr>
             <a:r>
-              <a:t>On 13 circuits (QFT, QV, ESU2, QAOA, BV,</a:t>
+              <a:t>Only track passes that produce new opportunities:</a:t>
             </a:r>
           </a:p>
           <a:p>
@@ -3599,7 +3596,7 @@
               </a:defRPr>
             </a:pPr>
             <a:r>
-              <a:t>Heisenberg at 50-100Q on FakeTorino):</a:t>
+              <a:t>  _opt_pass_changed: 2Q gate removed (exposes</a:t>
             </a:r>
           </a:p>
           <a:p>
@@ -3615,7 +3612,7 @@
               </a:defRPr>
             </a:pPr>
             <a:r>
-              <a:t>Pre-loop passes (ConsolidateBlocks, UnitarySynthesis)</a:t>
+              <a:t>    longer 1Q runs for next iteration)</a:t>
             </a:r>
           </a:p>
           <a:p>
@@ -3631,7 +3628,7 @@
               </a:defRPr>
             </a:pPr>
             <a:r>
-              <a:t>handle the bulk of 2Q gate reduction</a:t>
+              <a:t>  _opt_1q_consolidated: rotations merged (shortens</a:t>
             </a:r>
           </a:p>
           <a:p>
@@ -3647,7 +3644,7 @@
               </a:defRPr>
             </a:pPr>
             <a:r>
-              <a:t>Final iteration is always a no-op confirmation</a:t>
+              <a:t>    1Q runs for better decomposition)</a:t>
             </a:r>
           </a:p>
           <a:p>
@@ -3662,8 +3659,37 @@
                 <a:latin typeface="Calibri"/>
               </a:defRPr>
             </a:pPr>
-            <a:r>
-              <a:t>Different workloads may behave differently</a:t>
+          </a:p>
+          <a:p>
+            <a:pPr>
+              <a:spcAft>
+                <a:spcPts val="400"/>
+              </a:spcAft>
+              <a:defRPr sz="1200" b="0">
+                <a:solidFill>
+                  <a:srgbClr val="333333"/>
+                </a:solidFill>
+                <a:latin typeface="Calibri"/>
+              </a:defRPr>
+            </a:pPr>
+            <a:r>
+              <a:t>Optimize1qGatesDecomposition is a consumer, not a</a:t>
+            </a:r>
+          </a:p>
+          <a:p>
+            <a:pPr>
+              <a:spcAft>
+                <a:spcPts val="400"/>
+              </a:spcAft>
+              <a:defRPr sz="1200" b="0">
+                <a:solidFill>
+                  <a:srgbClr val="333333"/>
+                </a:solidFill>
+                <a:latin typeface="Calibri"/>
+              </a:defRPr>
+            </a:pPr>
+            <a:r>
+              <a:t>producer -- it doesn't drive the loop</a:t>
             </a:r>
           </a:p>
         </p:txBody>
@@ -3676,7 +3702,7 @@
         </p:nvSpPr>
         <p:spPr>
           <a:xfrm>
-            <a:off x="457200" y="3200400"/>
+            <a:off x="457200" y="3383280"/>
             <a:ext cx="8229600" cy="274320"/>
           </a:xfrm>
           <a:prstGeom prst="rect">
@@ -3699,7 +3725,7 @@
               </a:defRPr>
             </a:pPr>
             <a:r>
-              <a:t>Changed-Flag Prototype: Iterations Saved, No Regressions</a:t>
+              <a:t>Results: Zero Regression vs FixedPoint (A/B tested)</a:t>
             </a:r>
           </a:p>
         </p:txBody>
@@ -3713,8 +3739,8 @@
           <p:nvPr/>
         </p:nvGraphicFramePr>
         <p:xfrm>
-          <a:off x="457200" y="3566160"/>
-          <a:ext cx="7315200" cy="2103120"/>
+          <a:off x="457200" y="3703320"/>
+          <a:ext cx="7772400" cy="2103120"/>
         </p:xfrm>
         <a:graphic>
           <a:graphicData uri="http://schemas.openxmlformats.org/drawingml/2006/table">
@@ -3723,10 +3749,11 @@
                 <a:tableStyleId>{5C22544A-7EE6-4342-B048-85BDC9FD1C3A}</a:tableStyleId>
               </a:tblPr>
               <a:tblGrid>
-                <a:gridCol w="1828800"/>
-                <a:gridCol w="1280160"/>
-                <a:gridCol w="1463040"/>
-                <a:gridCol w="1280160"/>
+                <a:gridCol w="1645920"/>
+                <a:gridCol w="1188720"/>
+                <a:gridCol w="1371600"/>
+                <a:gridCol w="1188720"/>
+                <a:gridCol w="914400"/>
                 <a:gridCol w="1463040"/>
               </a:tblGrid>
               <a:tr h="300445">
@@ -3816,7 +3843,7 @@
                         </a:defRPr>
                       </a:pPr>
                       <a:r>
-                        <a:t>2Q Gates</a:t>
+                        <a:t>Total Gates</a:t>
                       </a:r>
                     </a:p>
                   </a:txBody>
@@ -3840,7 +3867,7 @@
                         </a:defRPr>
                       </a:pPr>
                       <a:r>
-                        <a:t>Regressed?</a:t>
+                        <a:t>Depth</a:t>
                       </a:r>
                     </a:p>
                   </a:txBody>
@@ -3850,6 +3877,30 @@
                     </a:solidFill>
                   </a:tcPr>
                 </a:tc>
+                <a:tc>
+                  <a:txBody>
+                    <a:bodyPr/>
+                    <a:lstStyle/>
+                    <a:p>
+                      <a:pPr>
+                        <a:defRPr sz="1100" b="1">
+                          <a:solidFill>
+                            <a:srgbClr val="FFFFFF"/>
+                          </a:solidFill>
+                          <a:latin typeface="Calibri"/>
+                        </a:defRPr>
+                      </a:pPr>
+                      <a:r>
+                        <a:t>Regressed?</a:t>
+                      </a:r>
+                    </a:p>
+                  </a:txBody>
+                  <a:tcPr anchor="ctr">
+                    <a:solidFill>
+                      <a:srgbClr val="0530AD"/>
+                    </a:solidFill>
+                  </a:tcPr>
+                </a:tc>
               </a:tr>
               <a:tr h="300445">
                 <a:tc>
@@ -3926,7 +3977,7 @@
                         </a:defRPr>
                       </a:pPr>
                       <a:r>
-                        <a:t>9,528</a:t>
+                        <a:t>37,687</a:t>
                       </a:r>
                     </a:p>
                   </a:txBody>
@@ -3946,7 +3997,27 @@
                         </a:defRPr>
                       </a:pPr>
                       <a:r>
-                        <a:t>No</a:t>
+                        <a:t>5,404</a:t>
+                      </a:r>
+                    </a:p>
+                  </a:txBody>
+                  <a:tcPr anchor="ctr"/>
+                </a:tc>
+                <a:tc>
+                  <a:txBody>
+                    <a:bodyPr/>
+                    <a:lstStyle/>
+                    <a:p>
+                      <a:pPr>
+                        <a:defRPr sz="1100">
+                          <a:solidFill>
+                            <a:srgbClr val="333333"/>
+                          </a:solidFill>
+                          <a:latin typeface="Calibri"/>
+                        </a:defRPr>
+                      </a:pPr>
+                      <a:r>
+                        <a:t>No (0 delta)</a:t>
                       </a:r>
                     </a:p>
                   </a:txBody>
@@ -4064,7 +4135,7 @@
                         </a:defRPr>
                       </a:pPr>
                       <a:r>
-                        <a:t>No</a:t>
+                        <a:t>—</a:t>
                       </a:r>
                     </a:p>
                   </a:txBody>
@@ -4074,88 +4145,6 @@
                     </a:solidFill>
                   </a:tcPr>
                 </a:tc>
-              </a:tr>
-              <a:tr h="300445">
-                <a:tc>
-                  <a:txBody>
-                    <a:bodyPr/>
-                    <a:lstStyle/>
-                    <a:p>
-                      <a:pPr>
-                        <a:defRPr sz="1100">
-                          <a:solidFill>
-                            <a:srgbClr val="333333"/>
-                          </a:solidFill>
-                          <a:latin typeface="Calibri"/>
-                        </a:defRPr>
-                      </a:pPr>
-                      <a:r>
-                        <a:t>EfficientSU2_100</a:t>
-                      </a:r>
-                    </a:p>
-                  </a:txBody>
-                  <a:tcPr anchor="ctr"/>
-                </a:tc>
-                <a:tc>
-                  <a:txBody>
-                    <a:bodyPr/>
-                    <a:lstStyle/>
-                    <a:p>
-                      <a:pPr>
-                        <a:defRPr sz="1100">
-                          <a:solidFill>
-                            <a:srgbClr val="333333"/>
-                          </a:solidFill>
-                          <a:latin typeface="Calibri"/>
-                        </a:defRPr>
-                      </a:pPr>
-                      <a:r>
-                        <a:t>2</a:t>
-                      </a:r>
-                    </a:p>
-                  </a:txBody>
-                  <a:tcPr anchor="ctr"/>
-                </a:tc>
-                <a:tc>
-                  <a:txBody>
-                    <a:bodyPr/>
-                    <a:lstStyle/>
-                    <a:p>
-                      <a:pPr>
-                        <a:defRPr sz="1100">
-                          <a:solidFill>
-                            <a:srgbClr val="333333"/>
-                          </a:solidFill>
-                          <a:latin typeface="Calibri"/>
-                        </a:defRPr>
-                      </a:pPr>
-                      <a:r>
-                        <a:t>1</a:t>
-                      </a:r>
-                    </a:p>
-                  </a:txBody>
-                  <a:tcPr anchor="ctr"/>
-                </a:tc>
-                <a:tc>
-                  <a:txBody>
-                    <a:bodyPr/>
-                    <a:lstStyle/>
-                    <a:p>
-                      <a:pPr>
-                        <a:defRPr sz="1100">
-                          <a:solidFill>
-                            <a:srgbClr val="333333"/>
-                          </a:solidFill>
-                          <a:latin typeface="Calibri"/>
-                        </a:defRPr>
-                      </a:pPr>
-                      <a:r>
-                        <a:t>297</a:t>
-                      </a:r>
-                    </a:p>
-                  </a:txBody>
-                  <a:tcPr anchor="ctr"/>
-                </a:tc>
                 <a:tc>
                   <a:txBody>
                     <a:bodyPr/>
@@ -4171,28 +4160,6 @@
                       </a:pPr>
                       <a:r>
                         <a:t>No</a:t>
-                      </a:r>
-                    </a:p>
-                  </a:txBody>
-                  <a:tcPr anchor="ctr"/>
-                </a:tc>
-              </a:tr>
-              <a:tr h="300445">
-                <a:tc>
-                  <a:txBody>
-                    <a:bodyPr/>
-                    <a:lstStyle/>
-                    <a:p>
-                      <a:pPr>
-                        <a:defRPr sz="1100">
-                          <a:solidFill>
-                            <a:srgbClr val="333333"/>
-                          </a:solidFill>
-                          <a:latin typeface="Calibri"/>
-                        </a:defRPr>
-                      </a:pPr>
-                      <a:r>
-                        <a:t>QAOA_100</a:t>
                       </a:r>
                     </a:p>
                   </a:txBody>
@@ -4202,21 +4169,145 @@
                     </a:solidFill>
                   </a:tcPr>
                 </a:tc>
-                <a:tc>
-                  <a:txBody>
-                    <a:bodyPr/>
-                    <a:lstStyle/>
-                    <a:p>
-                      <a:pPr>
-                        <a:defRPr sz="1100">
-                          <a:solidFill>
-                            <a:srgbClr val="333333"/>
-                          </a:solidFill>
-                          <a:latin typeface="Calibri"/>
-                        </a:defRPr>
-                      </a:pPr>
-                      <a:r>
-                        <a:t>3</a:t>
+              </a:tr>
+              <a:tr h="300445">
+                <a:tc>
+                  <a:txBody>
+                    <a:bodyPr/>
+                    <a:lstStyle/>
+                    <a:p>
+                      <a:pPr>
+                        <a:defRPr sz="1100">
+                          <a:solidFill>
+                            <a:srgbClr val="333333"/>
+                          </a:solidFill>
+                          <a:latin typeface="Calibri"/>
+                        </a:defRPr>
+                      </a:pPr>
+                      <a:r>
+                        <a:t>EfficientSU2_100</a:t>
+                      </a:r>
+                    </a:p>
+                  </a:txBody>
+                  <a:tcPr anchor="ctr"/>
+                </a:tc>
+                <a:tc>
+                  <a:txBody>
+                    <a:bodyPr/>
+                    <a:lstStyle/>
+                    <a:p>
+                      <a:pPr>
+                        <a:defRPr sz="1100">
+                          <a:solidFill>
+                            <a:srgbClr val="333333"/>
+                          </a:solidFill>
+                          <a:latin typeface="Calibri"/>
+                        </a:defRPr>
+                      </a:pPr>
+                      <a:r>
+                        <a:t>2</a:t>
+                      </a:r>
+                    </a:p>
+                  </a:txBody>
+                  <a:tcPr anchor="ctr"/>
+                </a:tc>
+                <a:tc>
+                  <a:txBody>
+                    <a:bodyPr/>
+                    <a:lstStyle/>
+                    <a:p>
+                      <a:pPr>
+                        <a:defRPr sz="1100">
+                          <a:solidFill>
+                            <a:srgbClr val="333333"/>
+                          </a:solidFill>
+                          <a:latin typeface="Calibri"/>
+                        </a:defRPr>
+                      </a:pPr>
+                      <a:r>
+                        <a:t>1</a:t>
+                      </a:r>
+                    </a:p>
+                  </a:txBody>
+                  <a:tcPr anchor="ctr"/>
+                </a:tc>
+                <a:tc>
+                  <a:txBody>
+                    <a:bodyPr/>
+                    <a:lstStyle/>
+                    <a:p>
+                      <a:pPr>
+                        <a:defRPr sz="1100">
+                          <a:solidFill>
+                            <a:srgbClr val="333333"/>
+                          </a:solidFill>
+                          <a:latin typeface="Calibri"/>
+                        </a:defRPr>
+                      </a:pPr>
+                      <a:r>
+                        <a:t>1,494</a:t>
+                      </a:r>
+                    </a:p>
+                  </a:txBody>
+                  <a:tcPr anchor="ctr"/>
+                </a:tc>
+                <a:tc>
+                  <a:txBody>
+                    <a:bodyPr/>
+                    <a:lstStyle/>
+                    <a:p>
+                      <a:pPr>
+                        <a:defRPr sz="1100">
+                          <a:solidFill>
+                            <a:srgbClr val="333333"/>
+                          </a:solidFill>
+                          <a:latin typeface="Calibri"/>
+                        </a:defRPr>
+                      </a:pPr>
+                      <a:r>
+                        <a:t>330</a:t>
+                      </a:r>
+                    </a:p>
+                  </a:txBody>
+                  <a:tcPr anchor="ctr"/>
+                </a:tc>
+                <a:tc>
+                  <a:txBody>
+                    <a:bodyPr/>
+                    <a:lstStyle/>
+                    <a:p>
+                      <a:pPr>
+                        <a:defRPr sz="1100">
+                          <a:solidFill>
+                            <a:srgbClr val="333333"/>
+                          </a:solidFill>
+                          <a:latin typeface="Calibri"/>
+                        </a:defRPr>
+                      </a:pPr>
+                      <a:r>
+                        <a:t>No (0 delta)</a:t>
+                      </a:r>
+                    </a:p>
+                  </a:txBody>
+                  <a:tcPr anchor="ctr"/>
+                </a:tc>
+              </a:tr>
+              <a:tr h="300445">
+                <a:tc>
+                  <a:txBody>
+                    <a:bodyPr/>
+                    <a:lstStyle/>
+                    <a:p>
+                      <a:pPr>
+                        <a:defRPr sz="1100">
+                          <a:solidFill>
+                            <a:srgbClr val="333333"/>
+                          </a:solidFill>
+                          <a:latin typeface="Calibri"/>
+                        </a:defRPr>
+                      </a:pPr>
+                      <a:r>
+                        <a:t>QAOA_100</a:t>
                       </a:r>
                     </a:p>
                   </a:txBody>
@@ -4240,7 +4331,7 @@
                         </a:defRPr>
                       </a:pPr>
                       <a:r>
-                        <a:t>1</a:t>
+                        <a:t>3</a:t>
                       </a:r>
                     </a:p>
                   </a:txBody>
@@ -4264,7 +4355,7 @@
                         </a:defRPr>
                       </a:pPr>
                       <a:r>
-                        <a:t>186</a:t>
+                        <a:t>1</a:t>
                       </a:r>
                     </a:p>
                   </a:txBody>
@@ -4288,7 +4379,7 @@
                         </a:defRPr>
                       </a:pPr>
                       <a:r>
-                        <a:t>No</a:t>
+                        <a:t>2,137</a:t>
                       </a:r>
                     </a:p>
                   </a:txBody>
@@ -4298,125 +4389,21 @@
                     </a:solidFill>
                   </a:tcPr>
                 </a:tc>
-              </a:tr>
-              <a:tr h="300445">
-                <a:tc>
-                  <a:txBody>
-                    <a:bodyPr/>
-                    <a:lstStyle/>
-                    <a:p>
-                      <a:pPr>
-                        <a:defRPr sz="1100">
-                          <a:solidFill>
-                            <a:srgbClr val="333333"/>
-                          </a:solidFill>
-                          <a:latin typeface="Calibri"/>
-                        </a:defRPr>
-                      </a:pPr>
-                      <a:r>
-                        <a:t>BV_100</a:t>
-                      </a:r>
-                    </a:p>
-                  </a:txBody>
-                  <a:tcPr anchor="ctr"/>
-                </a:tc>
-                <a:tc>
-                  <a:txBody>
-                    <a:bodyPr/>
-                    <a:lstStyle/>
-                    <a:p>
-                      <a:pPr>
-                        <a:defRPr sz="1100">
-                          <a:solidFill>
-                            <a:srgbClr val="333333"/>
-                          </a:solidFill>
-                          <a:latin typeface="Calibri"/>
-                        </a:defRPr>
-                      </a:pPr>
-                      <a:r>
-                        <a:t>2</a:t>
-                      </a:r>
-                    </a:p>
-                  </a:txBody>
-                  <a:tcPr anchor="ctr"/>
-                </a:tc>
-                <a:tc>
-                  <a:txBody>
-                    <a:bodyPr/>
-                    <a:lstStyle/>
-                    <a:p>
-                      <a:pPr>
-                        <a:defRPr sz="1100">
-                          <a:solidFill>
-                            <a:srgbClr val="333333"/>
-                          </a:solidFill>
-                          <a:latin typeface="Calibri"/>
-                        </a:defRPr>
-                      </a:pPr>
-                      <a:r>
-                        <a:t>1</a:t>
-                      </a:r>
-                    </a:p>
-                  </a:txBody>
-                  <a:tcPr anchor="ctr"/>
-                </a:tc>
-                <a:tc>
-                  <a:txBody>
-                    <a:bodyPr/>
-                    <a:lstStyle/>
-                    <a:p>
-                      <a:pPr>
-                        <a:defRPr sz="1100">
-                          <a:solidFill>
-                            <a:srgbClr val="333333"/>
-                          </a:solidFill>
-                          <a:latin typeface="Calibri"/>
-                        </a:defRPr>
-                      </a:pPr>
-                      <a:r>
-                        <a:t>196</a:t>
-                      </a:r>
-                    </a:p>
-                  </a:txBody>
-                  <a:tcPr anchor="ctr"/>
-                </a:tc>
-                <a:tc>
-                  <a:txBody>
-                    <a:bodyPr/>
-                    <a:lstStyle/>
-                    <a:p>
-                      <a:pPr>
-                        <a:defRPr sz="1100">
-                          <a:solidFill>
-                            <a:srgbClr val="333333"/>
-                          </a:solidFill>
-                          <a:latin typeface="Calibri"/>
-                        </a:defRPr>
-                      </a:pPr>
-                      <a:r>
-                        <a:t>No</a:t>
-                      </a:r>
-                    </a:p>
-                  </a:txBody>
-                  <a:tcPr anchor="ctr"/>
-                </a:tc>
-              </a:tr>
-              <a:tr h="300450">
-                <a:tc>
-                  <a:txBody>
-                    <a:bodyPr/>
-                    <a:lstStyle/>
-                    <a:p>
-                      <a:pPr>
-                        <a:defRPr sz="1100">
-                          <a:solidFill>
-                            <a:srgbClr val="333333"/>
-                          </a:solidFill>
-                          <a:latin typeface="Calibri"/>
-                        </a:defRPr>
-                      </a:pPr>
-                      <a:r>
-                        <a:t>Heisenberg_100</a:t>
+                <a:tc>
+                  <a:txBody>
+                    <a:bodyPr/>
+                    <a:lstStyle/>
+                    <a:p>
+                      <a:pPr>
+                        <a:defRPr sz="1100">
+                          <a:solidFill>
+                            <a:srgbClr val="333333"/>
+                          </a:solidFill>
+                          <a:latin typeface="Calibri"/>
+                        </a:defRPr>
+                      </a:pPr>
+                      <a:r>
+                        <a:t>323</a:t>
                       </a:r>
                     </a:p>
                   </a:txBody>
@@ -4440,7 +4427,7 @@
                         </a:defRPr>
                       </a:pPr>
                       <a:r>
-                        <a:t>2</a:t>
+                        <a:t>No (0 delta)</a:t>
                       </a:r>
                     </a:p>
                   </a:txBody>
@@ -4450,6 +4437,48 @@
                     </a:solidFill>
                   </a:tcPr>
                 </a:tc>
+              </a:tr>
+              <a:tr h="300445">
+                <a:tc>
+                  <a:txBody>
+                    <a:bodyPr/>
+                    <a:lstStyle/>
+                    <a:p>
+                      <a:pPr>
+                        <a:defRPr sz="1100">
+                          <a:solidFill>
+                            <a:srgbClr val="333333"/>
+                          </a:solidFill>
+                          <a:latin typeface="Calibri"/>
+                        </a:defRPr>
+                      </a:pPr>
+                      <a:r>
+                        <a:t>BV_100</a:t>
+                      </a:r>
+                    </a:p>
+                  </a:txBody>
+                  <a:tcPr anchor="ctr"/>
+                </a:tc>
+                <a:tc>
+                  <a:txBody>
+                    <a:bodyPr/>
+                    <a:lstStyle/>
+                    <a:p>
+                      <a:pPr>
+                        <a:defRPr sz="1100">
+                          <a:solidFill>
+                            <a:srgbClr val="333333"/>
+                          </a:solidFill>
+                          <a:latin typeface="Calibri"/>
+                        </a:defRPr>
+                      </a:pPr>
+                      <a:r>
+                        <a:t>2</a:t>
+                      </a:r>
+                    </a:p>
+                  </a:txBody>
+                  <a:tcPr anchor="ctr"/>
+                </a:tc>
                 <a:tc>
                   <a:txBody>
                     <a:bodyPr/>
@@ -4465,6 +4494,88 @@
                       </a:pPr>
                       <a:r>
                         <a:t>1</a:t>
+                      </a:r>
+                    </a:p>
+                  </a:txBody>
+                  <a:tcPr anchor="ctr"/>
+                </a:tc>
+                <a:tc>
+                  <a:txBody>
+                    <a:bodyPr/>
+                    <a:lstStyle/>
+                    <a:p>
+                      <a:pPr>
+                        <a:defRPr sz="1100">
+                          <a:solidFill>
+                            <a:srgbClr val="333333"/>
+                          </a:solidFill>
+                          <a:latin typeface="Calibri"/>
+                        </a:defRPr>
+                      </a:pPr>
+                      <a:r>
+                        <a:t>196</a:t>
+                      </a:r>
+                    </a:p>
+                  </a:txBody>
+                  <a:tcPr anchor="ctr"/>
+                </a:tc>
+                <a:tc>
+                  <a:txBody>
+                    <a:bodyPr/>
+                    <a:lstStyle/>
+                    <a:p>
+                      <a:pPr>
+                        <a:defRPr sz="1100">
+                          <a:solidFill>
+                            <a:srgbClr val="333333"/>
+                          </a:solidFill>
+                          <a:latin typeface="Calibri"/>
+                        </a:defRPr>
+                      </a:pPr>
+                      <a:r>
+                        <a:t>—</a:t>
+                      </a:r>
+                    </a:p>
+                  </a:txBody>
+                  <a:tcPr anchor="ctr"/>
+                </a:tc>
+                <a:tc>
+                  <a:txBody>
+                    <a:bodyPr/>
+                    <a:lstStyle/>
+                    <a:p>
+                      <a:pPr>
+                        <a:defRPr sz="1100">
+                          <a:solidFill>
+                            <a:srgbClr val="333333"/>
+                          </a:solidFill>
+                          <a:latin typeface="Calibri"/>
+                        </a:defRPr>
+                      </a:pPr>
+                      <a:r>
+                        <a:t>No</a:t>
+                      </a:r>
+                    </a:p>
+                  </a:txBody>
+                  <a:tcPr anchor="ctr"/>
+                </a:tc>
+              </a:tr>
+              <a:tr h="300450">
+                <a:tc>
+                  <a:txBody>
+                    <a:bodyPr/>
+                    <a:lstStyle/>
+                    <a:p>
+                      <a:pPr>
+                        <a:defRPr sz="1100">
+                          <a:solidFill>
+                            <a:srgbClr val="333333"/>
+                          </a:solidFill>
+                          <a:latin typeface="Calibri"/>
+                        </a:defRPr>
+                      </a:pPr>
+                      <a:r>
+                        <a:t>Heisenberg_100</a:t>
                       </a:r>
                     </a:p>
                   </a:txBody>
@@ -4488,7 +4599,7 @@
                         </a:defRPr>
                       </a:pPr>
                       <a:r>
-                        <a:t>891</a:t>
+                        <a:t>2</a:t>
                       </a:r>
                     </a:p>
                   </a:txBody>
@@ -4512,7 +4623,7 @@
                         </a:defRPr>
                       </a:pPr>
                       <a:r>
-                        <a:t>No</a:t>
+                        <a:t>1</a:t>
                       </a:r>
                     </a:p>
                   </a:txBody>
@@ -4522,6 +4633,78 @@
                     </a:solidFill>
                   </a:tcPr>
                 </a:tc>
+                <a:tc>
+                  <a:txBody>
+                    <a:bodyPr/>
+                    <a:lstStyle/>
+                    <a:p>
+                      <a:pPr>
+                        <a:defRPr sz="1100">
+                          <a:solidFill>
+                            <a:srgbClr val="333333"/>
+                          </a:solidFill>
+                          <a:latin typeface="Calibri"/>
+                        </a:defRPr>
+                      </a:pPr>
+                      <a:r>
+                        <a:t>891</a:t>
+                      </a:r>
+                    </a:p>
+                  </a:txBody>
+                  <a:tcPr anchor="ctr">
+                    <a:solidFill>
+                      <a:srgbClr val="F5F5F5"/>
+                    </a:solidFill>
+                  </a:tcPr>
+                </a:tc>
+                <a:tc>
+                  <a:txBody>
+                    <a:bodyPr/>
+                    <a:lstStyle/>
+                    <a:p>
+                      <a:pPr>
+                        <a:defRPr sz="1100">
+                          <a:solidFill>
+                            <a:srgbClr val="333333"/>
+                          </a:solidFill>
+                          <a:latin typeface="Calibri"/>
+                        </a:defRPr>
+                      </a:pPr>
+                      <a:r>
+                        <a:t>—</a:t>
+                      </a:r>
+                    </a:p>
+                  </a:txBody>
+                  <a:tcPr anchor="ctr">
+                    <a:solidFill>
+                      <a:srgbClr val="F5F5F5"/>
+                    </a:solidFill>
+                  </a:tcPr>
+                </a:tc>
+                <a:tc>
+                  <a:txBody>
+                    <a:bodyPr/>
+                    <a:lstStyle/>
+                    <a:p>
+                      <a:pPr>
+                        <a:defRPr sz="1100">
+                          <a:solidFill>
+                            <a:srgbClr val="333333"/>
+                          </a:solidFill>
+                          <a:latin typeface="Calibri"/>
+                        </a:defRPr>
+                      </a:pPr>
+                      <a:r>
+                        <a:t>No</a:t>
+                      </a:r>
+                    </a:p>
+                  </a:txBody>
+                  <a:tcPr anchor="ctr">
+                    <a:solidFill>
+                      <a:srgbClr val="F5F5F5"/>
+                    </a:solidFill>
+                  </a:tcPr>
+                </a:tc>
               </a:tr>
             </a:tbl>
           </a:graphicData>
@@ -4535,7 +4718,7 @@
         </p:nvSpPr>
         <p:spPr>
           <a:xfrm>
-            <a:off x="457200" y="5852160"/>
+            <a:off x="457200" y="5943600"/>
             <a:ext cx="8229600" cy="457200"/>
           </a:xfrm>
           <a:prstGeom prst="rect">
@@ -4558,7 +4741,7 @@
               </a:defRPr>
             </a:pPr>
             <a:r>
-              <a:t>Proposal: Replace FixedPoint with a direct "changed" flag -- each pass reports whether it modified 2Q gates, and the loop exits when no pass reports changes. Preserves the loop for circuits where later iterations do find opportunities. Needs validation on broader circuit set.</a:t>
+              <a:t>Both 2Q and 1Q optimization preserved. Loop exits when neither opportunity-producing pass finds work. Removes 4 analysis passes (Size, Depth, FixedPoint x2) per iteration. Branch: pass-manager-investigation (commit efc12cf7c).</a:t>
             </a:r>
           </a:p>
         </p:txBody>
@@ -5140,7 +5323,7 @@
               </a:defRPr>
             </a:pPr>
             <a:r>
-              <a:t>Key insight: Speedup comes from memory access patterns, not threading. remove_1q_sequence() / replace_block() / remove_op_node() modify petgraph's StableGraph edge lists after every item, invalidating CPU cache lines. Batching all reads first keeps the cache warm. Rayon ON vs OFF shows no difference.</a:t>
+              <a:t>Key insight: Separating compute from mutation enables both cache-friendly access AND rayon parallelism. Serial mode shows 1.85x from batching alone (cache-warm reads). Rayon adds further speedup on release builds (4.7-6.5x within these passes). Combined: 1.5-1.6x end-to-end on QFT circuits.</a:t>
             </a:r>
           </a:p>
         </p:txBody>
@@ -5345,7 +5528,7 @@
               </a:defRPr>
             </a:pPr>
             <a:r>
-              <a:t>2. Compute-Then-Apply: Benchmark Results</a:t>
+              <a:t>2. Compute-Then-Apply: Benchmark Results (Release Build)</a:t>
             </a:r>
           </a:p>
         </p:txBody>
@@ -5381,7 +5564,7 @@
               </a:defRPr>
             </a:pPr>
             <a:r>
-              <a:t>FakeTorino (133Q heavy-hex), optimization level 2, 5 runs per circuit, mean reported</a:t>
+              <a:t>FakeTorino (133Q heavy-hex), optimization level 2, QISKIT_BUILD_PROFILE=release, 5 runs mean</a:t>
             </a:r>
           </a:p>
         </p:txBody>
@@ -5417,7 +5600,7 @@
               </a:defRPr>
             </a:pPr>
             <a:r>
-              <a:t>Remote Server (Intel Xeon, 160 vCPUs) -- Rayon ON</a:t>
+              <a:t>Default Mode (Rayon ON) -- Remote Server</a:t>
             </a:r>
           </a:p>
         </p:txBody>
@@ -5579,7 +5762,7 @@
                         </a:defRPr>
                       </a:pPr>
                       <a:r>
-                        <a:t>2.626</a:t>
+                        <a:t>0.196</a:t>
                       </a:r>
                     </a:p>
                   </a:txBody>
@@ -5599,7 +5782,7 @@
                         </a:defRPr>
                       </a:pPr>
                       <a:r>
-                        <a:t>2.051</a:t>
+                        <a:t>0.129</a:t>
                       </a:r>
                     </a:p>
                   </a:txBody>
@@ -5611,15 +5794,15 @@
                     <a:lstStyle/>
                     <a:p>
                       <a:pPr>
-                        <a:defRPr sz="1100">
-                          <a:solidFill>
-                            <a:srgbClr val="333333"/>
-                          </a:solidFill>
-                          <a:latin typeface="Calibri"/>
-                        </a:defRPr>
-                      </a:pPr>
-                      <a:r>
-                        <a:t>1.28x</a:t>
+                        <a:defRPr sz="1100" b="1">
+                          <a:solidFill>
+                            <a:srgbClr val="1A803E"/>
+                          </a:solidFill>
+                          <a:latin typeface="Calibri"/>
+                        </a:defRPr>
+                      </a:pPr>
+                      <a:r>
+                        <a:t>1.52x</a:t>
                       </a:r>
                     </a:p>
                   </a:txBody>
@@ -5665,7 +5848,7 @@
                         </a:defRPr>
                       </a:pPr>
                       <a:r>
-                        <a:t>6.321</a:t>
+                        <a:t>0.456</a:t>
                       </a:r>
                     </a:p>
                   </a:txBody>
@@ -5689,7 +5872,7 @@
                         </a:defRPr>
                       </a:pPr>
                       <a:r>
-                        <a:t>4.605</a:t>
+                        <a:t>0.288</a:t>
                       </a:r>
                     </a:p>
                   </a:txBody>
@@ -5713,7 +5896,7 @@
                         </a:defRPr>
                       </a:pPr>
                       <a:r>
-                        <a:t>1.37x</a:t>
+                        <a:t>1.58x</a:t>
                       </a:r>
                     </a:p>
                   </a:txBody>
@@ -5759,7 +5942,7 @@
                         </a:defRPr>
                       </a:pPr>
                       <a:r>
-                        <a:t>0.303</a:t>
+                        <a:t>0.012</a:t>
                       </a:r>
                     </a:p>
                   </a:txBody>
@@ -5779,7 +5962,7 @@
                         </a:defRPr>
                       </a:pPr>
                       <a:r>
-                        <a:t>0.293</a:t>
+                        <a:t>0.013</a:t>
                       </a:r>
                     </a:p>
                   </a:txBody>
@@ -5799,7 +5982,7 @@
                         </a:defRPr>
                       </a:pPr>
                       <a:r>
-                        <a:t>1.03x</a:t>
+                        <a:t>~same</a:t>
                       </a:r>
                     </a:p>
                   </a:txBody>
@@ -5845,7 +6028,7 @@
                         </a:defRPr>
                       </a:pPr>
                       <a:r>
-                        <a:t>0.489</a:t>
+                        <a:t>0.019</a:t>
                       </a:r>
                     </a:p>
                   </a:txBody>
@@ -5869,7 +6052,7 @@
                         </a:defRPr>
                       </a:pPr>
                       <a:r>
-                        <a:t>0.350</a:t>
+                        <a:t>0.018</a:t>
                       </a:r>
                     </a:p>
                   </a:txBody>
@@ -5885,15 +6068,15 @@
                     <a:lstStyle/>
                     <a:p>
                       <a:pPr>
-                        <a:defRPr sz="1100" b="1">
-                          <a:solidFill>
-                            <a:srgbClr val="1A803E"/>
-                          </a:solidFill>
-                          <a:latin typeface="Calibri"/>
-                        </a:defRPr>
-                      </a:pPr>
-                      <a:r>
-                        <a:t>1.40x</a:t>
+                        <a:defRPr sz="1100">
+                          <a:solidFill>
+                            <a:srgbClr val="333333"/>
+                          </a:solidFill>
+                          <a:latin typeface="Calibri"/>
+                        </a:defRPr>
+                      </a:pPr>
+                      <a:r>
+                        <a:t>~same</a:t>
                       </a:r>
                     </a:p>
                   </a:txBody>
@@ -5939,7 +6122,7 @@
                         </a:defRPr>
                       </a:pPr>
                       <a:r>
-                        <a:t>1.167</a:t>
+                        <a:t>0.060</a:t>
                       </a:r>
                     </a:p>
                   </a:txBody>
@@ -5959,7 +6142,7 @@
                         </a:defRPr>
                       </a:pPr>
                       <a:r>
-                        <a:t>1.013</a:t>
+                        <a:t>0.054</a:t>
                       </a:r>
                     </a:p>
                   </a:txBody>
@@ -5971,15 +6154,15 @@
                     <a:lstStyle/>
                     <a:p>
                       <a:pPr>
-                        <a:defRPr sz="1100" b="1">
-                          <a:solidFill>
-                            <a:srgbClr val="1A803E"/>
-                          </a:solidFill>
-                          <a:latin typeface="Calibri"/>
-                        </a:defRPr>
-                      </a:pPr>
-                      <a:r>
-                        <a:t>1.15x</a:t>
+                        <a:defRPr sz="1100">
+                          <a:solidFill>
+                            <a:srgbClr val="333333"/>
+                          </a:solidFill>
+                          <a:latin typeface="Calibri"/>
+                        </a:defRPr>
+                      </a:pPr>
+                      <a:r>
+                        <a:t>1.11x</a:t>
                       </a:r>
                     </a:p>
                   </a:txBody>
@@ -6025,7 +6208,7 @@
                         </a:defRPr>
                       </a:pPr>
                       <a:r>
-                        <a:t>3.385</a:t>
+                        <a:t>0.164</a:t>
                       </a:r>
                     </a:p>
                   </a:txBody>
@@ -6049,7 +6232,7 @@
                         </a:defRPr>
                       </a:pPr>
                       <a:r>
-                        <a:t>3.128</a:t>
+                        <a:t>0.154</a:t>
                       </a:r>
                     </a:p>
                   </a:txBody>
@@ -6073,7 +6256,7 @@
                         </a:defRPr>
                       </a:pPr>
                       <a:r>
-                        <a:t>1.08x</a:t>
+                        <a:t>1.06x</a:t>
                       </a:r>
                     </a:p>
                   </a:txBody>
@@ -6119,7 +6302,7 @@
               </a:defRPr>
             </a:pPr>
             <a:r>
-              <a:t>Remote Server -- Rayon OFF (serial mode)</a:t>
+              <a:t>Serial Mode (Rayon OFF) -- Remote Server</a:t>
             </a:r>
           </a:p>
         </p:txBody>
@@ -6281,7 +6464,7 @@
                         </a:defRPr>
                       </a:pPr>
                       <a:r>
-                        <a:t>2.700</a:t>
+                        <a:t>1.128</a:t>
                       </a:r>
                     </a:p>
                   </a:txBody>
@@ -6301,7 +6484,7 @@
                         </a:defRPr>
                       </a:pPr>
                       <a:r>
-                        <a:t>2.175</a:t>
+                        <a:t>0.609</a:t>
                       </a:r>
                     </a:p>
                   </a:txBody>
@@ -6313,15 +6496,15 @@
                     <a:lstStyle/>
                     <a:p>
                       <a:pPr>
-                        <a:defRPr sz="1100">
-                          <a:solidFill>
-                            <a:srgbClr val="333333"/>
-                          </a:solidFill>
-                          <a:latin typeface="Calibri"/>
-                        </a:defRPr>
-                      </a:pPr>
-                      <a:r>
-                        <a:t>1.24x</a:t>
+                        <a:defRPr sz="1100" b="1">
+                          <a:solidFill>
+                            <a:srgbClr val="1A803E"/>
+                          </a:solidFill>
+                          <a:latin typeface="Calibri"/>
+                        </a:defRPr>
+                      </a:pPr>
+                      <a:r>
+                        <a:t>1.85x</a:t>
                       </a:r>
                     </a:p>
                   </a:txBody>
@@ -6367,7 +6550,7 @@
                         </a:defRPr>
                       </a:pPr>
                       <a:r>
-                        <a:t>6.374</a:t>
+                        <a:t>2.648</a:t>
                       </a:r>
                     </a:p>
                   </a:txBody>
@@ -6391,7 +6574,7 @@
                         </a:defRPr>
                       </a:pPr>
                       <a:r>
-                        <a:t>4.491</a:t>
+                        <a:t>1.407</a:t>
                       </a:r>
                     </a:p>
                   </a:txBody>
@@ -6415,7 +6598,7 @@
                         </a:defRPr>
                       </a:pPr>
                       <a:r>
-                        <a:t>1.42x</a:t>
+                        <a:t>1.88x</a:t>
                       </a:r>
                     </a:p>
                   </a:txBody>
@@ -6461,7 +6644,7 @@
                         </a:defRPr>
                       </a:pPr>
                       <a:r>
-                        <a:t>0.299</a:t>
+                        <a:t>0.012</a:t>
                       </a:r>
                     </a:p>
                   </a:txBody>
@@ -6481,7 +6664,7 @@
                         </a:defRPr>
                       </a:pPr>
                       <a:r>
-                        <a:t>0.293</a:t>
+                        <a:t>0.012</a:t>
                       </a:r>
                     </a:p>
                   </a:txBody>
@@ -6501,7 +6684,7 @@
                         </a:defRPr>
                       </a:pPr>
                       <a:r>
-                        <a:t>1.02x</a:t>
+                        <a:t>~same</a:t>
                       </a:r>
                     </a:p>
                   </a:txBody>
@@ -6547,7 +6730,7 @@
                         </a:defRPr>
                       </a:pPr>
                       <a:r>
-                        <a:t>0.494</a:t>
+                        <a:t>0.019</a:t>
                       </a:r>
                     </a:p>
                   </a:txBody>
@@ -6571,7 +6754,7 @@
                         </a:defRPr>
                       </a:pPr>
                       <a:r>
-                        <a:t>0.350</a:t>
+                        <a:t>0.019</a:t>
                       </a:r>
                     </a:p>
                   </a:txBody>
@@ -6587,15 +6770,15 @@
                     <a:lstStyle/>
                     <a:p>
                       <a:pPr>
-                        <a:defRPr sz="1100" b="1">
-                          <a:solidFill>
-                            <a:srgbClr val="1A803E"/>
-                          </a:solidFill>
-                          <a:latin typeface="Calibri"/>
-                        </a:defRPr>
-                      </a:pPr>
-                      <a:r>
-                        <a:t>1.41x</a:t>
+                        <a:defRPr sz="1100">
+                          <a:solidFill>
+                            <a:srgbClr val="333333"/>
+                          </a:solidFill>
+                          <a:latin typeface="Calibri"/>
+                        </a:defRPr>
+                      </a:pPr>
+                      <a:r>
+                        <a:t>~same</a:t>
                       </a:r>
                     </a:p>
                   </a:txBody>
@@ -6641,7 +6824,7 @@
                         </a:defRPr>
                       </a:pPr>
                       <a:r>
-                        <a:t>1.273</a:t>
+                        <a:t>0.305</a:t>
                       </a:r>
                     </a:p>
                   </a:txBody>
@@ -6661,7 +6844,7 @@
                         </a:defRPr>
                       </a:pPr>
                       <a:r>
-                        <a:t>1.134</a:t>
+                        <a:t>0.264</a:t>
                       </a:r>
                     </a:p>
                   </a:txBody>
@@ -6673,15 +6856,15 @@
                     <a:lstStyle/>
                     <a:p>
                       <a:pPr>
-                        <a:defRPr sz="1100" b="1">
-                          <a:solidFill>
-                            <a:srgbClr val="1A803E"/>
-                          </a:solidFill>
-                          <a:latin typeface="Calibri"/>
-                        </a:defRPr>
-                      </a:pPr>
-                      <a:r>
-                        <a:t>1.12x</a:t>
+                        <a:defRPr sz="1100">
+                          <a:solidFill>
+                            <a:srgbClr val="333333"/>
+                          </a:solidFill>
+                          <a:latin typeface="Calibri"/>
+                        </a:defRPr>
+                      </a:pPr>
+                      <a:r>
+                        <a:t>1.16x</a:t>
                       </a:r>
                     </a:p>
                   </a:txBody>
@@ -6727,7 +6910,7 @@
                         </a:defRPr>
                       </a:pPr>
                       <a:r>
-                        <a:t>3.429</a:t>
+                        <a:t>1.040</a:t>
                       </a:r>
                     </a:p>
                   </a:txBody>
@@ -6751,7 +6934,7 @@
                         </a:defRPr>
                       </a:pPr>
                       <a:r>
-                        <a:t>3.082</a:t>
+                        <a:t>0.999</a:t>
                       </a:r>
                     </a:p>
                   </a:txBody>
@@ -6775,7 +6958,7 @@
                         </a:defRPr>
                       </a:pPr>
                       <a:r>
-                        <a:t>1.11x</a:t>
+                        <a:t>1.04x</a:t>
                       </a:r>
                     </a:p>
                   </a:txBody>
@@ -6821,7 +7004,7 @@
               </a:defRPr>
             </a:pPr>
             <a:r>
-              <a:t>Rayon ON vs OFF (our branch) -- no measurable difference:</a:t>
+              <a:t>Rayon ON vs OFF -- Isolating Threading Contribution:</a:t>
             </a:r>
           </a:p>
         </p:txBody>
@@ -6836,7 +7019,7 @@
         </p:nvGraphicFramePr>
         <p:xfrm>
           <a:off x="274320" y="4251960"/>
-          <a:ext cx="5943600" cy="1097280"/>
+          <a:ext cx="7315200" cy="1097280"/>
         </p:xfrm>
         <a:graphic>
           <a:graphicData uri="http://schemas.openxmlformats.org/drawingml/2006/table">
@@ -6845,11 +7028,13 @@
                 <a:tableStyleId>{5C22544A-7EE6-4342-B048-85BDC9FD1C3A}</a:tableStyleId>
               </a:tblPr>
               <a:tblGrid>
-                <a:gridCol w="1188720"/>
-                <a:gridCol w="1188720"/>
-                <a:gridCol w="1188720"/>
-                <a:gridCol w="1188720"/>
-                <a:gridCol w="1188720"/>
+                <a:gridCol w="1097280"/>
+                <a:gridCol w="1005840"/>
+                <a:gridCol w="1005840"/>
+                <a:gridCol w="1097280"/>
+                <a:gridCol w="1005840"/>
+                <a:gridCol w="1005840"/>
+                <a:gridCol w="1097280"/>
               </a:tblGrid>
               <a:tr h="274320">
                 <a:tc>
@@ -6890,7 +7075,7 @@
                         </a:defRPr>
                       </a:pPr>
                       <a:r>
-                        <a:t>Remote ON</a:t>
+                        <a:t>Main: ON</a:t>
                       </a:r>
                     </a:p>
                   </a:txBody>
@@ -6914,7 +7099,7 @@
                         </a:defRPr>
                       </a:pPr>
                       <a:r>
-                        <a:t>Remote OFF</a:t>
+                        <a:t>Main: OFF</a:t>
                       </a:r>
                     </a:p>
                   </a:txBody>
@@ -6938,7 +7123,7 @@
                         </a:defRPr>
                       </a:pPr>
                       <a:r>
-                        <a:t>Local ON</a:t>
+                        <a:t>Main Rayon</a:t>
                       </a:r>
                     </a:p>
                   </a:txBody>
@@ -6962,7 +7147,7 @@
                         </a:defRPr>
                       </a:pPr>
                       <a:r>
-                        <a:t>Local OFF</a:t>
+                        <a:t>Ours: ON</a:t>
                       </a:r>
                     </a:p>
                   </a:txBody>
@@ -6972,6 +7157,54 @@
                     </a:solidFill>
                   </a:tcPr>
                 </a:tc>
+                <a:tc>
+                  <a:txBody>
+                    <a:bodyPr/>
+                    <a:lstStyle/>
+                    <a:p>
+                      <a:pPr>
+                        <a:defRPr sz="1100" b="1">
+                          <a:solidFill>
+                            <a:srgbClr val="FFFFFF"/>
+                          </a:solidFill>
+                          <a:latin typeface="Calibri"/>
+                        </a:defRPr>
+                      </a:pPr>
+                      <a:r>
+                        <a:t>Ours: OFF</a:t>
+                      </a:r>
+                    </a:p>
+                  </a:txBody>
+                  <a:tcPr anchor="ctr">
+                    <a:solidFill>
+                      <a:srgbClr val="0530AD"/>
+                    </a:solidFill>
+                  </a:tcPr>
+                </a:tc>
+                <a:tc>
+                  <a:txBody>
+                    <a:bodyPr/>
+                    <a:lstStyle/>
+                    <a:p>
+                      <a:pPr>
+                        <a:defRPr sz="1100" b="1">
+                          <a:solidFill>
+                            <a:srgbClr val="FFFFFF"/>
+                          </a:solidFill>
+                          <a:latin typeface="Calibri"/>
+                        </a:defRPr>
+                      </a:pPr>
+                      <a:r>
+                        <a:t>Ours Rayon</a:t>
+                      </a:r>
+                    </a:p>
+                  </a:txBody>
+                  <a:tcPr anchor="ctr">
+                    <a:solidFill>
+                      <a:srgbClr val="0530AD"/>
+                    </a:solidFill>
+                  </a:tcPr>
+                </a:tc>
               </a:tr>
               <a:tr h="274320">
                 <a:tc>
@@ -6988,7 +7221,7 @@
                         </a:defRPr>
                       </a:pPr>
                       <a:r>
-                        <a:t>QFT-100</a:t>
+                        <a:t>QFT-50</a:t>
                       </a:r>
                     </a:p>
                   </a:txBody>
@@ -7008,7 +7241,7 @@
                         </a:defRPr>
                       </a:pPr>
                       <a:r>
-                        <a:t>4.605</a:t>
+                        <a:t>0.196</a:t>
                       </a:r>
                     </a:p>
                   </a:txBody>
@@ -7028,7 +7261,7 @@
                         </a:defRPr>
                       </a:pPr>
                       <a:r>
-                        <a:t>4.491</a:t>
+                        <a:t>1.128</a:t>
                       </a:r>
                     </a:p>
                   </a:txBody>
@@ -7048,7 +7281,7 @@
                         </a:defRPr>
                       </a:pPr>
                       <a:r>
-                        <a:t>7.231</a:t>
+                        <a:t>5.8x</a:t>
                       </a:r>
                     </a:p>
                   </a:txBody>
@@ -7068,7 +7301,47 @@
                         </a:defRPr>
                       </a:pPr>
                       <a:r>
-                        <a:t>5.592</a:t>
+                        <a:t>0.129</a:t>
+                      </a:r>
+                    </a:p>
+                  </a:txBody>
+                  <a:tcPr anchor="ctr"/>
+                </a:tc>
+                <a:tc>
+                  <a:txBody>
+                    <a:bodyPr/>
+                    <a:lstStyle/>
+                    <a:p>
+                      <a:pPr>
+                        <a:defRPr sz="1100">
+                          <a:solidFill>
+                            <a:srgbClr val="333333"/>
+                          </a:solidFill>
+                          <a:latin typeface="Calibri"/>
+                        </a:defRPr>
+                      </a:pPr>
+                      <a:r>
+                        <a:t>0.609</a:t>
+                      </a:r>
+                    </a:p>
+                  </a:txBody>
+                  <a:tcPr anchor="ctr"/>
+                </a:tc>
+                <a:tc>
+                  <a:txBody>
+                    <a:bodyPr/>
+                    <a:lstStyle/>
+                    <a:p>
+                      <a:pPr>
+                        <a:defRPr sz="1100">
+                          <a:solidFill>
+                            <a:srgbClr val="333333"/>
+                          </a:solidFill>
+                          <a:latin typeface="Calibri"/>
+                        </a:defRPr>
+                      </a:pPr>
+                      <a:r>
+                        <a:t>4.7x</a:t>
                       </a:r>
                     </a:p>
                   </a:txBody>
@@ -7090,7 +7363,7 @@
                         </a:defRPr>
                       </a:pPr>
                       <a:r>
-                        <a:t>ESU2-100</a:t>
+                        <a:t>QFT-100</a:t>
                       </a:r>
                     </a:p>
                   </a:txBody>
@@ -7114,7 +7387,7 @@
                         </a:defRPr>
                       </a:pPr>
                       <a:r>
-                        <a:t>0.350</a:t>
+                        <a:t>0.456</a:t>
                       </a:r>
                     </a:p>
                   </a:txBody>
@@ -7138,7 +7411,7 @@
                         </a:defRPr>
                       </a:pPr>
                       <a:r>
-                        <a:t>0.350</a:t>
+                        <a:t>2.648</a:t>
                       </a:r>
                     </a:p>
                   </a:txBody>
@@ -7162,7 +7435,7 @@
                         </a:defRPr>
                       </a:pPr>
                       <a:r>
-                        <a:t>0.502</a:t>
+                        <a:t>5.8x</a:t>
                       </a:r>
                     </a:p>
                   </a:txBody>
@@ -7186,7 +7459,7 @@
                         </a:defRPr>
                       </a:pPr>
                       <a:r>
-                        <a:t>0.390</a:t>
+                        <a:t>0.288</a:t>
                       </a:r>
                     </a:p>
                   </a:txBody>
@@ -7196,6 +7469,54 @@
                     </a:solidFill>
                   </a:tcPr>
                 </a:tc>
+                <a:tc>
+                  <a:txBody>
+                    <a:bodyPr/>
+                    <a:lstStyle/>
+                    <a:p>
+                      <a:pPr>
+                        <a:defRPr sz="1100">
+                          <a:solidFill>
+                            <a:srgbClr val="333333"/>
+                          </a:solidFill>
+                          <a:latin typeface="Calibri"/>
+                        </a:defRPr>
+                      </a:pPr>
+                      <a:r>
+                        <a:t>1.407</a:t>
+                      </a:r>
+                    </a:p>
+                  </a:txBody>
+                  <a:tcPr anchor="ctr">
+                    <a:solidFill>
+                      <a:srgbClr val="F5F5F5"/>
+                    </a:solidFill>
+                  </a:tcPr>
+                </a:tc>
+                <a:tc>
+                  <a:txBody>
+                    <a:bodyPr/>
+                    <a:lstStyle/>
+                    <a:p>
+                      <a:pPr>
+                        <a:defRPr sz="1100">
+                          <a:solidFill>
+                            <a:srgbClr val="333333"/>
+                          </a:solidFill>
+                          <a:latin typeface="Calibri"/>
+                        </a:defRPr>
+                      </a:pPr>
+                      <a:r>
+                        <a:t>4.9x</a:t>
+                      </a:r>
+                    </a:p>
+                  </a:txBody>
+                  <a:tcPr anchor="ctr">
+                    <a:solidFill>
+                      <a:srgbClr val="F5F5F5"/>
+                    </a:solidFill>
+                  </a:tcPr>
+                </a:tc>
               </a:tr>
               <a:tr h="274320">
                 <a:tc>
@@ -7232,7 +7553,7 @@
                         </a:defRPr>
                       </a:pPr>
                       <a:r>
-                        <a:t>3.128</a:t>
+                        <a:t>0.164</a:t>
                       </a:r>
                     </a:p>
                   </a:txBody>
@@ -7252,7 +7573,7 @@
                         </a:defRPr>
                       </a:pPr>
                       <a:r>
-                        <a:t>3.082</a:t>
+                        <a:t>1.040</a:t>
                       </a:r>
                     </a:p>
                   </a:txBody>
@@ -7272,7 +7593,7 @@
                         </a:defRPr>
                       </a:pPr>
                       <a:r>
-                        <a:t>4.286</a:t>
+                        <a:t>6.3x</a:t>
                       </a:r>
                     </a:p>
                   </a:txBody>
@@ -7292,7 +7613,47 @@
                         </a:defRPr>
                       </a:pPr>
                       <a:r>
-                        <a:t>3.688</a:t>
+                        <a:t>0.154</a:t>
+                      </a:r>
+                    </a:p>
+                  </a:txBody>
+                  <a:tcPr anchor="ctr"/>
+                </a:tc>
+                <a:tc>
+                  <a:txBody>
+                    <a:bodyPr/>
+                    <a:lstStyle/>
+                    <a:p>
+                      <a:pPr>
+                        <a:defRPr sz="1100">
+                          <a:solidFill>
+                            <a:srgbClr val="333333"/>
+                          </a:solidFill>
+                          <a:latin typeface="Calibri"/>
+                        </a:defRPr>
+                      </a:pPr>
+                      <a:r>
+                        <a:t>0.999</a:t>
+                      </a:r>
+                    </a:p>
+                  </a:txBody>
+                  <a:tcPr anchor="ctr"/>
+                </a:tc>
+                <a:tc>
+                  <a:txBody>
+                    <a:bodyPr/>
+                    <a:lstStyle/>
+                    <a:p>
+                      <a:pPr>
+                        <a:defRPr sz="1100">
+                          <a:solidFill>
+                            <a:srgbClr val="333333"/>
+                          </a:solidFill>
+                          <a:latin typeface="Calibri"/>
+                        </a:defRPr>
+                      </a:pPr>
+                      <a:r>
+                        <a:t>6.5x</a:t>
                       </a:r>
                     </a:p>
                   </a:txBody>
@@ -7312,7 +7673,7 @@
         <p:spPr>
           <a:xfrm>
             <a:off x="274320" y="5577840"/>
-            <a:ext cx="8595360" cy="548640"/>
+            <a:ext cx="8595360" cy="640080"/>
           </a:xfrm>
           <a:prstGeom prst="roundRect">
             <a:avLst/>
@@ -7353,7 +7714,7 @@
               </a:defRPr>
             </a:pPr>
             <a:r>
-              <a:t>Takeaway: 15-42% speedup on 50-100 qubit circuits from cache-friendly DAG access. Identical speedup with rayon ON and OFF confirms the gain is purely from compute-then-apply batching. No regressions on small circuits. Rayon parallelism is ready for future 1000+ qubit circuits.</a:t>
+              <a:t>Takeaway: 1.5-1.6x end-to-end speedup on QFT circuits (rayon ON). In serial mode, restructuring alone gives 1.85-1.88x. Main already has rayon in SABRE (5-6x); our branch adds rayon to 3 optimization passes. Small circuits show no overhead. Gate counts identical.</a:t>
             </a:r>
           </a:p>
         </p:txBody>
@@ -8825,7 +9186,7 @@
                         </a:defRPr>
                       </a:pPr>
                       <a:r>
-                        <a:t>Prototype done</a:t>
+                        <a:t>Implemented + verified</a:t>
                       </a:r>
                     </a:p>
                   </a:txBody>
@@ -8845,7 +9206,7 @@
                         </a:defRPr>
                       </a:pPr>
                       <a:r>
-                        <a:t>Eliminates redundant confirmation iteration</a:t>
+                        <a:t>Skip redundant iterations, 0 regression</a:t>
                       </a:r>
                     </a:p>
                   </a:txBody>
@@ -8935,7 +9296,7 @@
                         </a:defRPr>
                       </a:pPr>
                       <a:r>
-                        <a:t>15-42% speedup on opt passes</a:t>
+                        <a:t>1.5-1.9x speedup (release build)</a:t>
                       </a:r>
                     </a:p>
                   </a:txBody>
@@ -9142,7 +9503,7 @@
               </a:defRPr>
             </a:pPr>
             <a:r>
-              <a:t>The L2 loop's convergence check (FixedPoint) always forces a redundant confirmation iteration</a:t>
+              <a:t>Optimization loop: track opportunity-producing passes, not consumers (solves idempotency problem)</a:t>
             </a:r>
           </a:p>
           <a:p>
@@ -9158,7 +9519,7 @@
               </a:defRPr>
             </a:pPr>
             <a:r>
-              <a:t>The parallelization hypothesis was wrong: actual gain is from cache-friendly memory access</a:t>
+              <a:t>Compute-then-apply: separating reads from writes enables both cache efficiency AND rayon parallelism</a:t>
             </a:r>
           </a:p>
           <a:p>
@@ -9265,7 +9626,7 @@
               </a:defRPr>
             </a:pPr>
             <a:r>
-              <a:t>Optimization loop: propose changed-flag approach for Level 2</a:t>
+              <a:t>Optimization loop: upstream PR with opportunity-driven flag approach</a:t>
             </a:r>
           </a:p>
           <a:p>

</xml_diff>

<commit_message>
Document related upstream PRs (16014, 15567, 13419) with comparison
Added Related Upstream PRs section to parallel_optimization_passes.md
comparing implementation approaches, blockers, and our advantages:
- 16014: non-deterministic ordering vs our deterministic merge
- 15567: OnceLock complexity vs our simple precompute pattern
- 13419: full rewrite vs our minimal focused change

Added corresponding slide (7 slides total) with comparison table and
recommendation to contribute via code review.

Co-Authored-By: Claude Opus 4.6 <noreply@anthropic.com>
</commit_message>
<xml_diff>
--- a/investigation/qiskit_transpiler_optimizations.pptx
+++ b/investigation/qiskit_transpiler_optimizations.pptx
@@ -11,6 +11,7 @@
     <p:sldId id="259" r:id="rId10"/>
     <p:sldId id="260" r:id="rId11"/>
     <p:sldId id="261" r:id="rId12"/>
+    <p:sldId id="262" r:id="rId13"/>
   </p:sldIdLst>
   <p:sldSz cx="9144000" cy="6858000" type="screen4x3"/>
   <p:notesSz cx="6858000" cy="9144000"/>
@@ -7776,6 +7777,801 @@
               </a:defRPr>
             </a:pPr>
             <a:r>
+              <a:t>2. Compute-Then-Apply: Related Upstream PRs</a:t>
+            </a:r>
+          </a:p>
+        </p:txBody>
+      </p:sp>
+      <p:sp>
+        <p:nvSpPr>
+          <p:cNvPr id="3" name="TextBox 2"/>
+          <p:cNvSpPr txBox="1"/>
+          <p:nvPr/>
+        </p:nvSpPr>
+        <p:spPr>
+          <a:xfrm>
+            <a:off x="457200" y="777240"/>
+            <a:ext cx="8229600" cy="274320"/>
+          </a:xfrm>
+          <a:prstGeom prst="rect">
+            <a:avLst/>
+          </a:prstGeom>
+          <a:noFill/>
+        </p:spPr>
+        <p:txBody>
+          <a:bodyPr wrap="square">
+            <a:spAutoFit/>
+          </a:bodyPr>
+          <a:lstStyle/>
+          <a:p>
+            <a:pPr algn="l">
+              <a:defRPr sz="1200" b="0">
+                <a:solidFill>
+                  <a:srgbClr val="666666"/>
+                </a:solidFill>
+                <a:latin typeface="Calibri"/>
+              </a:defRPr>
+            </a:pPr>
+            <a:r>
+              <a:t>Three open Qiskit PRs pursue the same goal. All unmerged and on hold (May 2026).</a:t>
+            </a:r>
+          </a:p>
+        </p:txBody>
+      </p:sp>
+      <p:graphicFrame>
+        <p:nvGraphicFramePr>
+          <p:cNvPr id="4" name="Table 3"/>
+          <p:cNvGraphicFramePr>
+            <a:graphicFrameLocks noGrp="1"/>
+          </p:cNvGraphicFramePr>
+          <p:nvPr/>
+        </p:nvGraphicFramePr>
+        <p:xfrm>
+          <a:off x="274320" y="1188720"/>
+          <a:ext cx="8595360" cy="1828800"/>
+        </p:xfrm>
+        <a:graphic>
+          <a:graphicData uri="http://schemas.openxmlformats.org/drawingml/2006/table">
+            <a:tbl>
+              <a:tblPr firstRow="1" bandRow="1">
+                <a:tableStyleId>{5C22544A-7EE6-4342-B048-85BDC9FD1C3A}</a:tableStyleId>
+              </a:tblPr>
+              <a:tblGrid>
+                <a:gridCol w="731520"/>
+                <a:gridCol w="1828800"/>
+                <a:gridCol w="2103120"/>
+                <a:gridCol w="1828800"/>
+                <a:gridCol w="2103120"/>
+              </a:tblGrid>
+              <a:tr h="457200">
+                <a:tc>
+                  <a:txBody>
+                    <a:bodyPr/>
+                    <a:lstStyle/>
+                    <a:p>
+                      <a:pPr>
+                        <a:defRPr sz="1100" b="1">
+                          <a:solidFill>
+                            <a:srgbClr val="FFFFFF"/>
+                          </a:solidFill>
+                          <a:latin typeface="Calibri"/>
+                        </a:defRPr>
+                      </a:pPr>
+                      <a:r>
+                        <a:t>PR</a:t>
+                      </a:r>
+                    </a:p>
+                  </a:txBody>
+                  <a:tcPr anchor="ctr">
+                    <a:solidFill>
+                      <a:srgbClr val="0530AD"/>
+                    </a:solidFill>
+                  </a:tcPr>
+                </a:tc>
+                <a:tc>
+                  <a:txBody>
+                    <a:bodyPr/>
+                    <a:lstStyle/>
+                    <a:p>
+                      <a:pPr>
+                        <a:defRPr sz="1100" b="1">
+                          <a:solidFill>
+                            <a:srgbClr val="FFFFFF"/>
+                          </a:solidFill>
+                          <a:latin typeface="Calibri"/>
+                        </a:defRPr>
+                      </a:pPr>
+                      <a:r>
+                        <a:t>Pass</a:t>
+                      </a:r>
+                    </a:p>
+                  </a:txBody>
+                  <a:tcPr anchor="ctr">
+                    <a:solidFill>
+                      <a:srgbClr val="0530AD"/>
+                    </a:solidFill>
+                  </a:tcPr>
+                </a:tc>
+                <a:tc>
+                  <a:txBody>
+                    <a:bodyPr/>
+                    <a:lstStyle/>
+                    <a:p>
+                      <a:pPr>
+                        <a:defRPr sz="1100" b="1">
+                          <a:solidFill>
+                            <a:srgbClr val="FFFFFF"/>
+                          </a:solidFill>
+                          <a:latin typeface="Calibri"/>
+                        </a:defRPr>
+                      </a:pPr>
+                      <a:r>
+                        <a:t>Their Approach</a:t>
+                      </a:r>
+                    </a:p>
+                  </a:txBody>
+                  <a:tcPr anchor="ctr">
+                    <a:solidFill>
+                      <a:srgbClr val="0530AD"/>
+                    </a:solidFill>
+                  </a:tcPr>
+                </a:tc>
+                <a:tc>
+                  <a:txBody>
+                    <a:bodyPr/>
+                    <a:lstStyle/>
+                    <a:p>
+                      <a:pPr>
+                        <a:defRPr sz="1100" b="1">
+                          <a:solidFill>
+                            <a:srgbClr val="FFFFFF"/>
+                          </a:solidFill>
+                          <a:latin typeface="Calibri"/>
+                        </a:defRPr>
+                      </a:pPr>
+                      <a:r>
+                        <a:t>Blocker</a:t>
+                      </a:r>
+                    </a:p>
+                  </a:txBody>
+                  <a:tcPr anchor="ctr">
+                    <a:solidFill>
+                      <a:srgbClr val="0530AD"/>
+                    </a:solidFill>
+                  </a:tcPr>
+                </a:tc>
+                <a:tc>
+                  <a:txBody>
+                    <a:bodyPr/>
+                    <a:lstStyle/>
+                    <a:p>
+                      <a:pPr>
+                        <a:defRPr sz="1100" b="1">
+                          <a:solidFill>
+                            <a:srgbClr val="FFFFFF"/>
+                          </a:solidFill>
+                          <a:latin typeface="Calibri"/>
+                        </a:defRPr>
+                      </a:pPr>
+                      <a:r>
+                        <a:t>Our Advantage</a:t>
+                      </a:r>
+                    </a:p>
+                  </a:txBody>
+                  <a:tcPr anchor="ctr">
+                    <a:solidFill>
+                      <a:srgbClr val="0530AD"/>
+                    </a:solidFill>
+                  </a:tcPr>
+                </a:tc>
+              </a:tr>
+              <a:tr h="457200">
+                <a:tc>
+                  <a:txBody>
+                    <a:bodyPr/>
+                    <a:lstStyle/>
+                    <a:p>
+                      <a:pPr>
+                        <a:defRPr sz="1100">
+                          <a:solidFill>
+                            <a:srgbClr val="333333"/>
+                          </a:solidFill>
+                          <a:latin typeface="Calibri"/>
+                        </a:defRPr>
+                      </a:pPr>
+                      <a:r>
+                        <a:t>#16014</a:t>
+                      </a:r>
+                    </a:p>
+                  </a:txBody>
+                  <a:tcPr anchor="ctr"/>
+                </a:tc>
+                <a:tc>
+                  <a:txBody>
+                    <a:bodyPr/>
+                    <a:lstStyle/>
+                    <a:p>
+                      <a:pPr>
+                        <a:defRPr sz="1100">
+                          <a:solidFill>
+                            <a:srgbClr val="333333"/>
+                          </a:solidFill>
+                          <a:latin typeface="Calibri"/>
+                        </a:defRPr>
+                      </a:pPr>
+                      <a:r>
+                        <a:t>CommutationAnalysis</a:t>
+                      </a:r>
+                    </a:p>
+                  </a:txBody>
+                  <a:tcPr anchor="ctr"/>
+                </a:tc>
+                <a:tc>
+                  <a:txBody>
+                    <a:bodyPr/>
+                    <a:lstStyle/>
+                    <a:p>
+                      <a:pPr>
+                        <a:defRPr sz="1100">
+                          <a:solidFill>
+                            <a:srgbClr val="333333"/>
+                          </a:solidFill>
+                          <a:latin typeface="Calibri"/>
+                        </a:defRPr>
+                      </a:pPr>
+                      <a:r>
+                        <a:t>fold+reduce with rayon</a:t>
+                      </a:r>
+                    </a:p>
+                  </a:txBody>
+                  <a:tcPr anchor="ctr"/>
+                </a:tc>
+                <a:tc>
+                  <a:txBody>
+                    <a:bodyPr/>
+                    <a:lstStyle/>
+                    <a:p>
+                      <a:pPr>
+                        <a:defRPr sz="1100">
+                          <a:solidFill>
+                            <a:srgbClr val="333333"/>
+                          </a:solidFill>
+                          <a:latin typeface="Calibri"/>
+                        </a:defRPr>
+                      </a:pPr>
+                      <a:r>
+                        <a:t>Non-deterministic order</a:t>
+                      </a:r>
+                    </a:p>
+                  </a:txBody>
+                  <a:tcPr anchor="ctr"/>
+                </a:tc>
+                <a:tc>
+                  <a:txBody>
+                    <a:bodyPr/>
+                    <a:lstStyle/>
+                    <a:p>
+                      <a:pPr>
+                        <a:defRPr sz="1100">
+                          <a:solidFill>
+                            <a:srgbClr val="333333"/>
+                          </a:solidFill>
+                          <a:latin typeface="Calibri"/>
+                        </a:defRPr>
+                      </a:pPr>
+                      <a:r>
+                        <a:t>Deterministic merge by qubit index</a:t>
+                      </a:r>
+                    </a:p>
+                  </a:txBody>
+                  <a:tcPr anchor="ctr"/>
+                </a:tc>
+              </a:tr>
+              <a:tr h="457200">
+                <a:tc>
+                  <a:txBody>
+                    <a:bodyPr/>
+                    <a:lstStyle/>
+                    <a:p>
+                      <a:pPr>
+                        <a:defRPr sz="1100">
+                          <a:solidFill>
+                            <a:srgbClr val="333333"/>
+                          </a:solidFill>
+                          <a:latin typeface="Calibri"/>
+                        </a:defRPr>
+                      </a:pPr>
+                      <a:r>
+                        <a:t>#15567</a:t>
+                      </a:r>
+                    </a:p>
+                  </a:txBody>
+                  <a:tcPr anchor="ctr">
+                    <a:solidFill>
+                      <a:srgbClr val="F5F5F5"/>
+                    </a:solidFill>
+                  </a:tcPr>
+                </a:tc>
+                <a:tc>
+                  <a:txBody>
+                    <a:bodyPr/>
+                    <a:lstStyle/>
+                    <a:p>
+                      <a:pPr>
+                        <a:defRPr sz="1100">
+                          <a:solidFill>
+                            <a:srgbClr val="333333"/>
+                          </a:solidFill>
+                          <a:latin typeface="Calibri"/>
+                        </a:defRPr>
+                      </a:pPr>
+                      <a:r>
+                        <a:t>Optimize1qGatesDecomp</a:t>
+                      </a:r>
+                    </a:p>
+                  </a:txBody>
+                  <a:tcPr anchor="ctr">
+                    <a:solidFill>
+                      <a:srgbClr val="F5F5F5"/>
+                    </a:solidFill>
+                  </a:tcPr>
+                </a:tc>
+                <a:tc>
+                  <a:txBody>
+                    <a:bodyPr/>
+                    <a:lstStyle/>
+                    <a:p>
+                      <a:pPr>
+                        <a:defRPr sz="1100">
+                          <a:solidFill>
+                            <a:srgbClr val="333333"/>
+                          </a:solidFill>
+                          <a:latin typeface="Calibri"/>
+                        </a:defRPr>
+                      </a:pPr>
+                      <a:r>
+                        <a:t>OnceLock lazy init, 100K threshold</a:t>
+                      </a:r>
+                    </a:p>
+                  </a:txBody>
+                  <a:tcPr anchor="ctr">
+                    <a:solidFill>
+                      <a:srgbClr val="F5F5F5"/>
+                    </a:solidFill>
+                  </a:tcPr>
+                </a:tc>
+                <a:tc>
+                  <a:txBody>
+                    <a:bodyPr/>
+                    <a:lstStyle/>
+                    <a:p>
+                      <a:pPr>
+                        <a:defRPr sz="1100">
+                          <a:solidFill>
+                            <a:srgbClr val="333333"/>
+                          </a:solidFill>
+                          <a:latin typeface="Calibri"/>
+                        </a:defRPr>
+                      </a:pPr>
+                      <a:r>
+                        <a:t>Test failures, never triggers</a:t>
+                      </a:r>
+                    </a:p>
+                  </a:txBody>
+                  <a:tcPr anchor="ctr">
+                    <a:solidFill>
+                      <a:srgbClr val="F5F5F5"/>
+                    </a:solidFill>
+                  </a:tcPr>
+                </a:tc>
+                <a:tc>
+                  <a:txBody>
+                    <a:bodyPr/>
+                    <a:lstStyle/>
+                    <a:p>
+                      <a:pPr>
+                        <a:defRPr sz="1100">
+                          <a:solidFill>
+                            <a:srgbClr val="333333"/>
+                          </a:solidFill>
+                          <a:latin typeface="Calibri"/>
+                        </a:defRPr>
+                      </a:pPr>
+                      <a:r>
+                        <a:t>Simple precompute, threshold=500</a:t>
+                      </a:r>
+                    </a:p>
+                  </a:txBody>
+                  <a:tcPr anchor="ctr">
+                    <a:solidFill>
+                      <a:srgbClr val="F5F5F5"/>
+                    </a:solidFill>
+                  </a:tcPr>
+                </a:tc>
+              </a:tr>
+              <a:tr h="457200">
+                <a:tc>
+                  <a:txBody>
+                    <a:bodyPr/>
+                    <a:lstStyle/>
+                    <a:p>
+                      <a:pPr>
+                        <a:defRPr sz="1100">
+                          <a:solidFill>
+                            <a:srgbClr val="333333"/>
+                          </a:solidFill>
+                          <a:latin typeface="Calibri"/>
+                        </a:defRPr>
+                      </a:pPr>
+                      <a:r>
+                        <a:t>#13419</a:t>
+                      </a:r>
+                    </a:p>
+                  </a:txBody>
+                  <a:tcPr anchor="ctr"/>
+                </a:tc>
+                <a:tc>
+                  <a:txBody>
+                    <a:bodyPr/>
+                    <a:lstStyle/>
+                    <a:p>
+                      <a:pPr>
+                        <a:defRPr sz="1100">
+                          <a:solidFill>
+                            <a:srgbClr val="333333"/>
+                          </a:solidFill>
+                          <a:latin typeface="Calibri"/>
+                        </a:defRPr>
+                      </a:pPr>
+                      <a:r>
+                        <a:t>ConsolidateBlocks (rewrite)</a:t>
+                      </a:r>
+                    </a:p>
+                  </a:txBody>
+                  <a:tcPr anchor="ctr"/>
+                </a:tc>
+                <a:tc>
+                  <a:txBody>
+                    <a:bodyPr/>
+                    <a:lstStyle/>
+                    <a:p>
+                      <a:pPr>
+                        <a:defRPr sz="1100">
+                          <a:solidFill>
+                            <a:srgbClr val="333333"/>
+                          </a:solidFill>
+                          <a:latin typeface="Calibri"/>
+                        </a:defRPr>
+                      </a:pPr>
+                      <a:r>
+                        <a:t>Unified pass (86 commits)</a:t>
+                      </a:r>
+                    </a:p>
+                  </a:txBody>
+                  <a:tcPr anchor="ctr"/>
+                </a:tc>
+                <a:tc>
+                  <a:txBody>
+                    <a:bodyPr/>
+                    <a:lstStyle/>
+                    <a:p>
+                      <a:pPr>
+                        <a:defRPr sz="1100">
+                          <a:solidFill>
+                            <a:srgbClr val="333333"/>
+                          </a:solidFill>
+                          <a:latin typeface="Calibri"/>
+                        </a:defRPr>
+                      </a:pPr>
+                      <a:r>
+                        <a:t>Large scope</a:t>
+                      </a:r>
+                    </a:p>
+                  </a:txBody>
+                  <a:tcPr anchor="ctr"/>
+                </a:tc>
+                <a:tc>
+                  <a:txBody>
+                    <a:bodyPr/>
+                    <a:lstStyle/>
+                    <a:p>
+                      <a:pPr>
+                        <a:defRPr sz="1100">
+                          <a:solidFill>
+                            <a:srgbClr val="333333"/>
+                          </a:solidFill>
+                          <a:latin typeface="Calibri"/>
+                        </a:defRPr>
+                      </a:pPr>
+                      <a:r>
+                        <a:t>Minimal focused change, composable</a:t>
+                      </a:r>
+                    </a:p>
+                  </a:txBody>
+                  <a:tcPr anchor="ctr"/>
+                </a:tc>
+              </a:tr>
+            </a:tbl>
+          </a:graphicData>
+        </a:graphic>
+      </p:graphicFrame>
+      <p:sp>
+        <p:nvSpPr>
+          <p:cNvPr id="5" name="TextBox 4"/>
+          <p:cNvSpPr txBox="1"/>
+          <p:nvPr/>
+        </p:nvSpPr>
+        <p:spPr>
+          <a:xfrm>
+            <a:off x="457200" y="3291840"/>
+            <a:ext cx="8229600" cy="274320"/>
+          </a:xfrm>
+          <a:prstGeom prst="rect">
+            <a:avLst/>
+          </a:prstGeom>
+          <a:noFill/>
+        </p:spPr>
+        <p:txBody>
+          <a:bodyPr wrap="square">
+            <a:spAutoFit/>
+          </a:bodyPr>
+          <a:lstStyle/>
+          <a:p>
+            <a:pPr algn="l">
+              <a:defRPr sz="1400" b="1">
+                <a:solidFill>
+                  <a:srgbClr val="333333"/>
+                </a:solidFill>
+                <a:latin typeface="Calibri"/>
+              </a:defRPr>
+            </a:pPr>
+            <a:r>
+              <a:t>Key Implementation Differences</a:t>
+            </a:r>
+          </a:p>
+        </p:txBody>
+      </p:sp>
+      <p:sp>
+        <p:nvSpPr>
+          <p:cNvPr id="6" name="TextBox 5"/>
+          <p:cNvSpPr txBox="1"/>
+          <p:nvPr/>
+        </p:nvSpPr>
+        <p:spPr>
+          <a:xfrm>
+            <a:off x="457200" y="3566160"/>
+            <a:ext cx="8229600" cy="2286000"/>
+          </a:xfrm>
+          <a:prstGeom prst="rect">
+            <a:avLst/>
+          </a:prstGeom>
+          <a:noFill/>
+        </p:spPr>
+        <p:txBody>
+          <a:bodyPr wrap="square">
+            <a:spAutoFit/>
+          </a:bodyPr>
+          <a:lstStyle/>
+          <a:p>
+            <a:pPr>
+              <a:spcAft>
+                <a:spcPts val="200"/>
+              </a:spcAft>
+              <a:defRPr sz="1100" b="0">
+                <a:solidFill>
+                  <a:srgbClr val="666666"/>
+                </a:solidFill>
+                <a:latin typeface="Calibri"/>
+              </a:defRPr>
+            </a:pPr>
+            <a:r>
+              <a:t>#16014: Their fold+reduce merges IndexMaps from threads → non-deterministic iteration order (flagged by reviewer).</a:t>
+            </a:r>
+          </a:p>
+          <a:p>
+            <a:pPr>
+              <a:spcAft>
+                <a:spcPts val="200"/>
+              </a:spcAft>
+              <a:defRPr sz="1100" b="0">
+                <a:solidFill>
+                  <a:srgbClr val="666666"/>
+                </a:solidFill>
+                <a:latin typeface="Calibri"/>
+              </a:defRPr>
+            </a:pPr>
+            <a:r>
+              <a:t>    Ours: collect per-wire results into Vec ordered by qubit index, merge sequentially. Deterministic, zero overhead.</a:t>
+            </a:r>
+          </a:p>
+          <a:p>
+            <a:pPr>
+              <a:spcAft>
+                <a:spcPts val="200"/>
+              </a:spcAft>
+              <a:defRPr sz="1100" b="0">
+                <a:solidFill>
+                  <a:srgbClr val="666666"/>
+                </a:solidFill>
+                <a:latin typeface="Calibri"/>
+              </a:defRPr>
+            </a:pPr>
+          </a:p>
+          <a:p>
+            <a:pPr>
+              <a:spcAft>
+                <a:spcPts val="200"/>
+              </a:spcAft>
+              <a:defRPr sz="1100" b="0">
+                <a:solidFill>
+                  <a:srgbClr val="666666"/>
+                </a:solidFill>
+                <a:latin typeface="Calibri"/>
+              </a:defRPr>
+            </a:pPr>
+            <a:r>
+              <a:t>#15567: OnceLock defers basis computation per-qubit with thread-safe lazy init — complex, threshold too high to trigger.</a:t>
+            </a:r>
+          </a:p>
+          <a:p>
+            <a:pPr>
+              <a:spcAft>
+                <a:spcPts val="200"/>
+              </a:spcAft>
+              <a:defRPr sz="1100" b="0">
+                <a:solidFill>
+                  <a:srgbClr val="666666"/>
+                </a:solidFill>
+                <a:latin typeface="Calibri"/>
+              </a:defRPr>
+            </a:pPr>
+            <a:r>
+              <a:t>    Ours: precompute_basis_data() upfront in one pass, then stateless process_run(). No sync overhead, practical threshold.</a:t>
+            </a:r>
+          </a:p>
+          <a:p>
+            <a:pPr>
+              <a:spcAft>
+                <a:spcPts val="200"/>
+              </a:spcAft>
+              <a:defRPr sz="1100" b="0">
+                <a:solidFill>
+                  <a:srgbClr val="666666"/>
+                </a:solidFill>
+                <a:latin typeface="Calibri"/>
+              </a:defRPr>
+            </a:pPr>
+          </a:p>
+          <a:p>
+            <a:pPr>
+              <a:spcAft>
+                <a:spcPts val="200"/>
+              </a:spcAft>
+              <a:defRPr sz="1100" b="0">
+                <a:solidFill>
+                  <a:srgbClr val="666666"/>
+                </a:solidFill>
+                <a:latin typeface="Calibri"/>
+              </a:defRPr>
+            </a:pPr>
+            <a:r>
+              <a:t>#13419: Full rewrite unifying 3 passes. Our compute-then-apply pattern is orthogonal and can be applied to their new pass.</a:t>
+            </a:r>
+          </a:p>
+        </p:txBody>
+      </p:sp>
+      <p:sp>
+        <p:nvSpPr>
+          <p:cNvPr id="7" name="Rounded Rectangle 6"/>
+          <p:cNvSpPr/>
+          <p:nvPr/>
+        </p:nvSpPr>
+        <p:spPr>
+          <a:xfrm>
+            <a:off x="274320" y="5669280"/>
+            <a:ext cx="8595360" cy="548640"/>
+          </a:xfrm>
+          <a:prstGeom prst="roundRect">
+            <a:avLst/>
+          </a:prstGeom>
+          <a:solidFill>
+            <a:srgbClr val="E8F0FE"/>
+          </a:solidFill>
+          <a:ln w="19050">
+            <a:solidFill>
+              <a:srgbClr val="0062FF"/>
+            </a:solidFill>
+          </a:ln>
+        </p:spPr>
+        <p:style>
+          <a:lnRef idx="1">
+            <a:schemeClr val="accent1"/>
+          </a:lnRef>
+          <a:fillRef idx="3">
+            <a:schemeClr val="accent1"/>
+          </a:fillRef>
+          <a:effectRef idx="2">
+            <a:schemeClr val="accent1"/>
+          </a:effectRef>
+          <a:fontRef idx="minor">
+            <a:schemeClr val="lt1"/>
+          </a:fontRef>
+        </p:style>
+        <p:txBody>
+          <a:bodyPr rtlCol="0" anchor="ctr" wrap="square"/>
+          <a:lstStyle/>
+          <a:p>
+            <a:pPr algn="ctr">
+              <a:defRPr sz="1100">
+                <a:solidFill>
+                  <a:srgbClr val="333333"/>
+                </a:solidFill>
+                <a:latin typeface="Calibri"/>
+              </a:defRPr>
+            </a:pPr>
+            <a:r>
+              <a:t>Recommendation: Contribute via code review on the open PRs. Our determinism fix directly solves #16014's blocker. Our precompute pattern simplifies #15567. Benchmark data validates practical thresholds for all three.</a:t>
+            </a:r>
+          </a:p>
+        </p:txBody>
+      </p:sp>
+    </p:spTree>
+  </p:cSld>
+  <p:clrMapOvr>
+    <a:masterClrMapping/>
+  </p:clrMapOvr>
+</p:sld>
+</file>
+
+<file path=ppt/slides/slide6.xml><?xml version="1.0" encoding="utf-8"?>
+<p:sld xmlns:a="http://schemas.openxmlformats.org/drawingml/2006/main" xmlns:p="http://schemas.openxmlformats.org/presentationml/2006/main" xmlns:r="http://schemas.openxmlformats.org/officeDocument/2006/relationships">
+  <p:cSld>
+    <p:bg>
+      <p:bgPr>
+        <a:solidFill>
+          <a:srgbClr val="FFFFFF"/>
+        </a:solidFill>
+        <a:effectLst/>
+      </p:bgPr>
+    </p:bg>
+    <p:spTree>
+      <p:nvGrpSpPr>
+        <p:cNvPr id="1" name=""/>
+        <p:cNvGrpSpPr/>
+        <p:nvPr/>
+      </p:nvGrpSpPr>
+      <p:grpSpPr/>
+      <p:sp>
+        <p:nvSpPr>
+          <p:cNvPr id="2" name="TextBox 1"/>
+          <p:cNvSpPr txBox="1"/>
+          <p:nvPr/>
+        </p:nvSpPr>
+        <p:spPr>
+          <a:xfrm>
+            <a:off x="457200" y="274320"/>
+            <a:ext cx="8229600" cy="457200"/>
+          </a:xfrm>
+          <a:prstGeom prst="rect">
+            <a:avLst/>
+          </a:prstGeom>
+          <a:noFill/>
+        </p:spPr>
+        <p:txBody>
+          <a:bodyPr wrap="square">
+            <a:spAutoFit/>
+          </a:bodyPr>
+          <a:lstStyle/>
+          <a:p>
+            <a:pPr algn="l">
+              <a:defRPr sz="2200" b="1">
+                <a:solidFill>
+                  <a:srgbClr val="0530AD"/>
+                </a:solidFill>
+                <a:latin typeface="Calibri"/>
+              </a:defRPr>
+            </a:pPr>
+            <a:r>
               <a:t>3. 3-Qubit Block Synthesis: Separability Splitting for -5% CX Gates</a:t>
             </a:r>
           </a:p>
@@ -8975,7 +9771,7 @@
 </p:sld>
 </file>
 
-<file path=ppt/slides/slide6.xml><?xml version="1.0" encoding="utf-8"?>
+<file path=ppt/slides/slide7.xml><?xml version="1.0" encoding="utf-8"?>
 <p:sld xmlns:a="http://schemas.openxmlformats.org/drawingml/2006/main" xmlns:p="http://schemas.openxmlformats.org/presentationml/2006/main" xmlns:r="http://schemas.openxmlformats.org/officeDocument/2006/relationships">
   <p:cSld>
     <p:bg>

</xml_diff>

<commit_message>
Add 1Q regression narrative to optimization loop slide
Co-Authored-By: Claude Opus 4.6 <noreply@anthropic.com>
</commit_message>
<xml_diff>
--- a/investigation/qiskit_transpiler_optimizations.pptx
+++ b/investigation/qiskit_transpiler_optimizations.pptx
@@ -3581,7 +3581,7 @@
               </a:defRPr>
             </a:pPr>
             <a:r>
-              <a:t>Only track passes that produce new opportunities:</a:t>
+              <a:t>Initial attempt: track only 2Q changes</a:t>
             </a:r>
           </a:p>
           <a:p>
@@ -3597,7 +3597,7 @@
               </a:defRPr>
             </a:pPr>
             <a:r>
-              <a:t>  _opt_pass_changed: 2Q gate removed (exposes</a:t>
+              <a:t>  → 0.18% 1Q regression on QFT (69 gates)</a:t>
             </a:r>
           </a:p>
           <a:p>
@@ -3613,7 +3613,7 @@
               </a:defRPr>
             </a:pPr>
             <a:r>
-              <a:t>    longer 1Q runs for next iteration)</a:t>
+              <a:t>  → rotation merges missed across iterations</a:t>
             </a:r>
           </a:p>
           <a:p>
@@ -3628,8 +3628,21 @@
                 <a:latin typeface="Calibri"/>
               </a:defRPr>
             </a:pPr>
-            <a:r>
-              <a:t>  _opt_1q_consolidated: rotations merged (shortens</a:t>
+          </a:p>
+          <a:p>
+            <a:pPr>
+              <a:spcAft>
+                <a:spcPts val="400"/>
+              </a:spcAft>
+              <a:defRPr sz="1200" b="1">
+                <a:solidFill>
+                  <a:srgbClr val="333333"/>
+                </a:solidFill>
+                <a:latin typeface="Calibri"/>
+              </a:defRPr>
+            </a:pPr>
+            <a:r>
+              <a:t>Fix: also track rotation consolidation</a:t>
             </a:r>
           </a:p>
           <a:p>
@@ -3645,7 +3658,7 @@
               </a:defRPr>
             </a:pPr>
             <a:r>
-              <a:t>    1Q runs for better decomposition)</a:t>
+              <a:t>  _opt_pass_changed: 2Q gate removed</a:t>
             </a:r>
           </a:p>
           <a:p>
@@ -3660,6 +3673,9 @@
                 <a:latin typeface="Calibri"/>
               </a:defRPr>
             </a:pPr>
+            <a:r>
+              <a:t>  _opt_1q_consolidated: rotations merged</a:t>
+            </a:r>
           </a:p>
           <a:p>
             <a:pPr>
@@ -3674,23 +3690,7 @@
               </a:defRPr>
             </a:pPr>
             <a:r>
-              <a:t>Optimize1qGatesDecomposition is a consumer, not a</a:t>
-            </a:r>
-          </a:p>
-          <a:p>
-            <a:pPr>
-              <a:spcAft>
-                <a:spcPts val="400"/>
-              </a:spcAft>
-              <a:defRPr sz="1200" b="0">
-                <a:solidFill>
-                  <a:srgbClr val="333333"/>
-                </a:solidFill>
-                <a:latin typeface="Calibri"/>
-              </a:defRPr>
-            </a:pPr>
-            <a:r>
-              <a:t>producer -- it doesn't drive the loop</a:t>
+              <a:t>  → zero regression (A/B verified)</a:t>
             </a:r>
           </a:p>
         </p:txBody>
@@ -4742,7 +4742,7 @@
               </a:defRPr>
             </a:pPr>
             <a:r>
-              <a:t>Both 2Q and 1Q optimization preserved. Loop exits when neither opportunity-producing pass finds work. Removes 4 analysis passes (Size, Depth, FixedPoint x2) per iteration. Branch: pass-manager-investigation (commit efc12cf7c).</a:t>
+              <a:t>Tracking rotation consolidation captures the CommutativeCancellation → Optimize1qGatesDecomposition cross-iteration benefit. Without it, skipping the extra iteration loses 1Q optimization on rotation-heavy circuits. With it: zero regression, fewer iterations, no analysis passes needed.</a:t>
             </a:r>
           </a:p>
         </p:txBody>

</xml_diff>